<commit_message>
Make vacation demo interactive within one rehearsal session
</commit_message>
<xml_diff>
--- a/demos/vacation-agent/talk/agent-vacation.pptx
+++ b/demos/vacation-agent/talk/agent-vacation.pptx
@@ -477,7 +477,7 @@
 </file>
 
 <file path=ppt/notesSlides/notesSlide1.xml><?xml version="1.0" encoding="utf-8"?>
-<p:notes xmlns:a="http://schemas.openxmlformats.org/drawingml/2006/main" xmlns:r="http://schemas.openxmlformats.org/officeDocument/2006/relationships" xmlns:p="http://schemas.openxmlformats.org/presentationml/2006/main">
+<p:notes xmlns:a="http://schemas.openxmlformats.org/drawingml/2006/main" xmlns:ns2="http://schemas.microsoft.com/office/powerpoint/2010/main" xmlns:p="http://schemas.openxmlformats.org/presentationml/2006/main">
   <p:cSld>
     <p:spTree>
       <p:nvGrpSpPr>
@@ -522,7 +522,7 @@
           <a:p>
             <a:r>
               <a:rPr lang="en-US" dirty="0"/>
-              <a:t>זמן: 00:00-00:40
+              <a:t>זמן: 00:00–00:40
 פתיחה: היום נשלח סוכן לחפש חופשה. יש לו תקציב, תנאים ואתכם. החופשה הזאת עוד לא עברה QA. המטרה שלנו היא להבין איך מחברים מודל שבוחר פעולה לדפדפן שבאמת יכול לבצע אותה. נתחיל באתר, ואז נפתח את מכסה המנוע.
 חשוב, ולהגיד פעם אחת בבירור: האתר והמלונות בדויים, ואין רכישה אמיתית. בגרסת התרגול המקומית הבחירות מתוסרטות ומסומנות כך. ריצה חיה של Jev ו-AWS מציגים רק אחרי שהשירותים חוברו ונבדקו.
 מעבר: חצי דקה עליי, ואז יוצאים לחופשה.</a:t>
@@ -557,7 +557,7 @@
     </p:spTree>
     <p:extLst>
       <p:ext uri="{BB962C8B-B14F-4D97-AF65-F5344CB8AC3E}">
-        <p14:creationId xmlns:p14="http://schemas.microsoft.com/office/powerpoint/2010/main" val="1024086991"/>
+        <ns2:creationId val="1024086991"/>
       </p:ext>
     </p:extLst>
   </p:cSld>
@@ -568,7 +568,7 @@
 </file>
 
 <file path=ppt/notesSlides/notesSlide10.xml><?xml version="1.0" encoding="utf-8"?>
-<p:notes xmlns:a="http://schemas.openxmlformats.org/drawingml/2006/main" xmlns:r="http://schemas.openxmlformats.org/officeDocument/2006/relationships" xmlns:p="http://schemas.openxmlformats.org/presentationml/2006/main">
+<p:notes xmlns:a="http://schemas.openxmlformats.org/drawingml/2006/main" xmlns:ns2="http://schemas.microsoft.com/office/powerpoint/2010/main" xmlns:p="http://schemas.openxmlformats.org/presentationml/2006/main">
   <p:cSld>
     <p:spTree>
       <p:nvGrpSpPr>
@@ -613,7 +613,7 @@
           <a:p>
             <a:r>
               <a:rPr lang="en-US" dirty="0"/>
-              <a:t>זמן: 11:20-12:50
+              <a:t>זמן: 11:30–13:00
 להצביע על שלושת הסימונים בקוד, בלי להקריא את כולו: 1 המצב, 2 האפשרויות, 3 המזהה שחוזר. client נוצר עם TypeSafeClient, ו-choice מגיע מאותו SDK. compactState נבנה אצלנו (src/compact.ts), והאפשרויות נגזרות מהדף (src/actions.ts). המזהה שחוזר הוא back_to_results או stop, אותם מזהים כמו בשקף הקודם. לפי המזהה הזה הקוד מוצא את הפעולה ב-registry (נראה את זה בשקף 13).
 הקוד בשקף לקוח מ-src/jev.ts. הוא נבדק מול ה-SDK האמיתי עם fetch מדומה, אבל לא הורץ מול השירות עצמו. צריך להתקין @typesafe-ai/sdk ולהגדיר TYPESAFE_API_KEY בצד השרת. המפתח לא נכנס לדף הדמו בדפדפן.
 להבהיר: הרשימה בשקף קצרה לצורך המחשה. במימוש, הרשימה נגזרת מהמצב העדכני. אנחנו לא מבקשים מהמודל להמציא selector.
@@ -649,7 +649,7 @@
     </p:spTree>
     <p:extLst>
       <p:ext uri="{BB962C8B-B14F-4D97-AF65-F5344CB8AC3E}">
-        <p14:creationId xmlns:p14="http://schemas.microsoft.com/office/powerpoint/2010/main" val="1024086991"/>
+        <ns2:creationId val="1024086991"/>
       </p:ext>
     </p:extLst>
   </p:cSld>
@@ -660,7 +660,7 @@
 </file>
 
 <file path=ppt/notesSlides/notesSlide11.xml><?xml version="1.0" encoding="utf-8"?>
-<p:notes xmlns:a="http://schemas.openxmlformats.org/drawingml/2006/main" xmlns:r="http://schemas.openxmlformats.org/officeDocument/2006/relationships" xmlns:p="http://schemas.openxmlformats.org/presentationml/2006/main">
+<p:notes xmlns:a="http://schemas.openxmlformats.org/drawingml/2006/main" xmlns:ns2="http://schemas.microsoft.com/office/powerpoint/2010/main" xmlns:p="http://schemas.openxmlformats.org/presentationml/2006/main">
   <p:cSld>
     <p:spTree>
       <p:nvGrpSpPr>
@@ -705,7 +705,7 @@
           <a:p>
             <a:r>
               <a:rPr lang="en-US" dirty="0"/>
-              <a:t>זמן: 12:50-13:50
+              <a:t>זמן: 13:00–14:30
 אפשר לקבל תשובה מושלמת מבחינת פורמט ולהיכנס למלון הלא נכון. בדוגמה: בדף של מלון B הפעולות הן select_hotel, back_to_results ו-stop. select_hotel הוא מזהה קיים ותקין, אבל מלון B לא נגיש, והקוד דוחה אותו. אפשר להראות את זה חי: npm run demo:vacation -- sold-out --chooser careless. זה ההבדל בין חוזה תקין להחלטה טובה.
 ה-Choice API מחזיר גם הסתברויות ו-confidence. ה-confidence מתאר כמה ההתפלגות מרוכזת. הוא לא ההסתברות שההזמנה נכונה.
 לכן לא נשים סף קסם של 90 אחוז ונלך לים. נבדוק תנאים, נעקוב אחרי התוצאה ונעצור כשצריך. חישובי תקציב ותאריכים נשארים בקוד.
@@ -741,7 +741,7 @@
     </p:spTree>
     <p:extLst>
       <p:ext uri="{BB962C8B-B14F-4D97-AF65-F5344CB8AC3E}">
-        <p14:creationId xmlns:p14="http://schemas.microsoft.com/office/powerpoint/2010/main" val="1024086991"/>
+        <ns2:creationId val="1024086991"/>
       </p:ext>
     </p:extLst>
   </p:cSld>
@@ -752,7 +752,7 @@
 </file>
 
 <file path=ppt/notesSlides/notesSlide12.xml><?xml version="1.0" encoding="utf-8"?>
-<p:notes xmlns:a="http://schemas.openxmlformats.org/drawingml/2006/main" xmlns:r="http://schemas.openxmlformats.org/officeDocument/2006/relationships" xmlns:p="http://schemas.openxmlformats.org/presentationml/2006/main">
+<p:notes xmlns:a="http://schemas.openxmlformats.org/drawingml/2006/main" xmlns:ns2="http://schemas.microsoft.com/office/powerpoint/2010/main" xmlns:p="http://schemas.openxmlformats.org/presentationml/2006/main">
   <p:cSld>
     <p:spTree>
       <p:nvGrpSpPr>
@@ -797,16 +797,8 @@
           <a:p>
             <a:r>
               <a:rPr lang="en-US" dirty="0"/>
-              <a:t>זמן: 13:50-15:40
-עכשיו נותנים שמות לחלקים, מימין לשמאל. Strands הוא SDK לבניית סוכנים וניהול כלים. Amazon Bedrock נותן לנו גישה למודל השפה שמתכנן ומעדכן את תת־המשימה. בתוך כלי הדפדפן שלנו יש לולאה קטנה שבונה מצב, מבקשת מ-Jev בחירה ומפעילה את Playwright. AgentCore Browser מספק את הדפדפן המרוחק.
-להדגיש את שני המודלים: המודל הגדול הוא המתכנן (מה המטרה עכשיו). Jev הוא הבוחר (איזו פעולה עכשיו).
-זו אינטגרציה שאנחנו בונים, לא חיבור רשמי של Jev שמגיע מוכן ב-Strands. לא חייבים לקרוא למתכנן הגדול בכל קליק. חוזרים אליו כשתת־המשימה הושלמה, כשהדרישות השתנו או כשנתקענו. זו החלטת תכנון, לא הבטחת ביצועים.
-ולג'וניורים: כדי להתחיל לא צריך AWS. Playwright מקומי ומודל אחד מספיקים. AWS נכנס כשרוצים להריץ בענן.
-מקורות: https://strandsagents.com/docs/user-guide/sdk/ ; https://docs.aws.amazon.com/bedrock-agentcore/latest/devguide/browser-tool.html ; https://docs.typesafe.ai/sdk/javascript
-איפה הדפדפן רץ (השורה התחתונה בשקף): כשמריצים בענן, הקוד מתחבר לסשן הדפדפן של AgentCore. Playwright הוא הנהג, ו-AgentCore Browser מספק את הרכב. Live View מאפשר להראות לקהל מה קורה בדפדפן בזמן אמת. כאן AWS מנהלת את סביבת הדפדפן עצמה, ולא רק נותנת שרת להריץ עליו סקריפט.
-אין להציג צילום קונסולה מדומה כאילו זו ריצה חיה. אם אין חיבור AWS מאומת, לומר במפורש: זה מסלול החיבור המתוכנן, ואת התרחיש אנחנו מדגימים מקומית.
-אפשר להזכיר בשאלות שיש הקלטה ושחזור עם custom browser ו-S3, אבל לא להעמיס את זה על ההסבר הראשי.
-מקור: https://docs.aws.amazon.com/bedrock-agentcore/latest/devguide/browser-tool.html</a:t>
+              <a:t>זמן: 14:30–16:00
+כל חיבור חי אופציונלי: --chooser jev, --browser agentcore, --planner strands. SDK tests אינם בדיקות מול השירותים. לא הרצנו בשינוי הזה Jev, AgentCore או Bedrock בתשלום. רק אחרי חזרה בחשבון מאושר אפשר להציג מסלול חי כבדוק. האתר הציבורי בדוי, ולמתכנן find_hotel אחד ללא קלט. עם --site-url הדפדפן פותח את הכתובת הציבורית. בלי הדגל, local טוען HTML ו-AgentCore משתמש ב-data URL.</a:t>
             </a:r>
             <a:endParaRPr lang="en-US" dirty="0"/>
           </a:p>
@@ -838,7 +830,7 @@
     </p:spTree>
     <p:extLst>
       <p:ext uri="{BB962C8B-B14F-4D97-AF65-F5344CB8AC3E}">
-        <p14:creationId xmlns:p14="http://schemas.microsoft.com/office/powerpoint/2010/main" val="1024086991"/>
+        <ns2:creationId val="1024086991"/>
       </p:ext>
     </p:extLst>
   </p:cSld>
@@ -849,7 +841,7 @@
 </file>
 
 <file path=ppt/notesSlides/notesSlide13.xml><?xml version="1.0" encoding="utf-8"?>
-<p:notes xmlns:a="http://schemas.openxmlformats.org/drawingml/2006/main" xmlns:r="http://schemas.openxmlformats.org/officeDocument/2006/relationships" xmlns:p="http://schemas.openxmlformats.org/presentationml/2006/main">
+<p:notes xmlns:a="http://schemas.openxmlformats.org/drawingml/2006/main" xmlns:ns2="http://schemas.microsoft.com/office/powerpoint/2010/main" xmlns:p="http://schemas.openxmlformats.org/presentationml/2006/main">
   <p:cSld>
     <p:spTree>
       <p:nvGrpSpPr>
@@ -894,11 +886,8 @@
           <a:p>
             <a:r>
               <a:rPr lang="en-US" dirty="0"/>
-              <a:t>זמן: 15:40-17:00
-נניח שהמודל בחר פעולה, ובינתיים האתר השתנה שוב. לכן לפני הלחיצה בודקים מחדש את המצב. מחפשים את הפעולה ברשימה, מוודאים שהיא מותרת כרגע, מבצעים, ואז קוראים את התוצאה. Playwright לא מחליף את הבדיקות העסקיות שלנו. למי שבא מ-QA automation: זו אותה בעיה כמו stale element, רק עם מודל באמצע.
-במערכת אמיתית עדיין יכול להיות race condition: האתר משתנה בין הקריאה לפעולה. בפעולה בעלת משמעות, כמו הזמנה, הבדיקה הסופית צריכה להיות בצד השרת: מחיר וזמינות בזמן ההזמנה. בדמו אין רכישה.
-הקוד בשקף לקוח מ-src/executor.ts, מקוצר (replan ו-done מחליפים שם אובייקטים קטנים). replan מחזיר שליטה למתכנן, ו-registry ממפה מזהים לפונקציות שהגדרנו.
-מקור ארכיטקטורה: תכנון הדמו שלנו. מקור מגבלות מודל: https://docs.typesafe.ai/model-jaggedness/jev-1.13</a:t>
+              <a:t>זמן: 16:00–18:00
+זה קיצור רעיוני של loop.ts ו-executor.ts, לא בלוק להעתקה. לפני לחיצה ממתינים ל-checkpoint, מיישמים את השינויים שבאו בזמן החלטת המודל ודוחים החלטה אם גרסת העולם השתנתה. אחר כך קוראים DOM עדכני ומוודאים דרך ה-registry. createRegistry מקבל getter לתנאים הנוכחיים ולא עותק של התקציב הראשון. תקציב ונגישות נשארים בקוד. Stop נבדק גם אחרי קריאות אסינכרוניות. אין פעולת pay ב-registry.</a:t>
             </a:r>
             <a:endParaRPr lang="en-US" dirty="0"/>
           </a:p>
@@ -930,7 +919,7 @@
     </p:spTree>
     <p:extLst>
       <p:ext uri="{BB962C8B-B14F-4D97-AF65-F5344CB8AC3E}">
-        <p14:creationId xmlns:p14="http://schemas.microsoft.com/office/powerpoint/2010/main" val="1024086991"/>
+        <ns2:creationId val="1024086991"/>
       </p:ext>
     </p:extLst>
   </p:cSld>
@@ -941,7 +930,7 @@
 </file>
 
 <file path=ppt/notesSlides/notesSlide14.xml><?xml version="1.0" encoding="utf-8"?>
-<p:notes xmlns:a="http://schemas.openxmlformats.org/drawingml/2006/main" xmlns:r="http://schemas.openxmlformats.org/officeDocument/2006/relationships" xmlns:p="http://schemas.openxmlformats.org/presentationml/2006/main">
+<p:notes xmlns:a="http://schemas.openxmlformats.org/drawingml/2006/main" xmlns:ns2="http://schemas.microsoft.com/office/powerpoint/2010/main" xmlns:p="http://schemas.openxmlformats.org/presentationml/2006/main">
   <p:cSld>
     <p:spTree>
       <p:nvGrpSpPr>
@@ -986,10 +975,8 @@
           <a:p>
             <a:r>
               <a:rPr lang="en-US" dirty="0"/>
-              <a:t>זמן: 17:00-19:00
-במה: להחזיר את הדמו למצב התקלה שנבחר. להציג מצב ופעולה לצד האתר. לפני שחושפים את הבחירה, לשאול את הקהל מה הם היו עושים. לקחת תשובה אחת. להתקדם צעד אחד בכל פעם. אם A מלא, חוזרים לתוצאות, ובסיבוב השני של הלולאה בוחרים את C ובודקים אותו. להדגיש: זו אותה לולאה שרצה שוב. אם התקציב ירד ל-500, עוצרים, כי שום מלון לא עומד בכל התנאים (השקף הבא).
-אם זה המסלול המתוסרט: לומר שאנחנו עוברים על תרחיש ההמחשה, לא על מדידת ביצועים של המודל. אם יש ריצה חיה: להראות את מה שקרה בפועל, גם אם הבחירה מפתיעה.
-הפואנטה: בהתחלה ראינו רק אתר שזז. עכשיו אפשר להסביר מה נכנס למודל, מה יצא ממנו ומה בדק הקוד. שתי דקות בלבד. אם מתעכבים, לדלג על הניחוש השני.</a:t>
+              <a:t>זמן: 18:00–20:30
+חזרו לאותו דפדפן ואותו run ID. לאחר sold-out A ו-next, select_hotel הישן נדחה world_changed. המשיכו ב-next, נקודת עצירה בכל פעם: בחירת back_to_results, לחיצה, בחירת open_hotel_C, לחיצה. next נוסף משאיר select_hotel של C ממתין לפני לחיצה. עוד לא מסיימים ריצה. בשקף 15 מורידים את התקציב ל-500 באותו סשן. כך שתי ההתערבויות וההתאוששות קורות באותה ריצה בלי restart.</a:t>
             </a:r>
             <a:endParaRPr lang="en-US" dirty="0"/>
           </a:p>
@@ -1021,7 +1008,7 @@
     </p:spTree>
     <p:extLst>
       <p:ext uri="{BB962C8B-B14F-4D97-AF65-F5344CB8AC3E}">
-        <p14:creationId xmlns:p14="http://schemas.microsoft.com/office/powerpoint/2010/main" val="1024086991"/>
+        <ns2:creationId val="1024086991"/>
       </p:ext>
     </p:extLst>
   </p:cSld>
@@ -1032,7 +1019,7 @@
 </file>
 
 <file path=ppt/notesSlides/notesSlide15.xml><?xml version="1.0" encoding="utf-8"?>
-<p:notes xmlns:a="http://schemas.openxmlformats.org/drawingml/2006/main" xmlns:r="http://schemas.openxmlformats.org/officeDocument/2006/relationships" xmlns:p="http://schemas.openxmlformats.org/presentationml/2006/main">
+<p:notes xmlns:a="http://schemas.openxmlformats.org/drawingml/2006/main" xmlns:ns2="http://schemas.microsoft.com/office/powerpoint/2010/main" xmlns:p="http://schemas.openxmlformats.org/presentationml/2006/main">
   <p:cSld>
     <p:spTree>
       <p:nvGrpSpPr>
@@ -1077,11 +1064,8 @@
           <a:p>
             <a:r>
               <a:rPr lang="en-US" dirty="0"/>
-              <a:t>זמן: 19:00-20:10
-אם הקהל בחר בתקציב, זו התוצאה החיה. אם בחר ב"המלון התמלא", להציג את השקף כ"ומה אם הייתם בוחרים בתקציב?".
-אם התקציב ירד ל-500 אירו, אין כאן פתרון תקין. הסוכן לא אמור להמציא נגישות או להעלות את התקציב על דעת עצמו. הוא יכול להגיד שלא מצא התאמה ולבקש החלטה. אפשר לשאול אם לשנות תאריכים או תקציב, אבל השינוי חייב להיות מפורש.
-זה גם הרגע להסביר למה יש stop ברשימת הפעולות. בלי אפשרות לעצור, אנחנו מאלצים את המודל לבחור פעולה גם כשאין אחת טובה. בנוסף, מגבילים את מספר הצעדים. חופשה של שלושה לילות לא צריכה לולאה של שלושה ימים.
-המצב והמחירים הם דוגמה בדויה. החישוב נעשה בקוד.</a:t>
+              <a:t>זמן: 20:30–22:30
+בריצה פעילה: budget 500 ואז run. אין מלון נגיש בתקציב, והטרמינל מציג no_match וממתין. הקלידו budget 600 ואז run; אם A נמכר, אפשר גם restore-hotel A. אותו run ID, אותה היסטוריה, אותו דפדפן. החרגות ישנות נמחקות כשגרסת העולם משתנה, ולכן אפשר להתאושש כשהתנאים מוקלים. stop מסיים. reset מבטל ריצה פעילה ומתחיל חדשה עם מזהה חדש באותו דפדפן.</a:t>
             </a:r>
             <a:endParaRPr lang="en-US" dirty="0"/>
           </a:p>
@@ -1113,7 +1097,7 @@
     </p:spTree>
     <p:extLst>
       <p:ext uri="{BB962C8B-B14F-4D97-AF65-F5344CB8AC3E}">
-        <p14:creationId xmlns:p14="http://schemas.microsoft.com/office/powerpoint/2010/main" val="1024086991"/>
+        <ns2:creationId val="1024086991"/>
       </p:ext>
     </p:extLst>
   </p:cSld>
@@ -1124,7 +1108,7 @@
 </file>
 
 <file path=ppt/notesSlides/notesSlide16.xml><?xml version="1.0" encoding="utf-8"?>
-<p:notes xmlns:a="http://schemas.openxmlformats.org/drawingml/2006/main" xmlns:r="http://schemas.openxmlformats.org/officeDocument/2006/relationships" xmlns:p="http://schemas.openxmlformats.org/presentationml/2006/main">
+<p:notes xmlns:a="http://schemas.openxmlformats.org/drawingml/2006/main" xmlns:ns2="http://schemas.microsoft.com/office/powerpoint/2010/main" xmlns:p="http://schemas.openxmlformats.org/presentationml/2006/main">
   <p:cSld>
     <p:spTree>
       <p:nvGrpSpPr>
@@ -1169,12 +1153,8 @@
           <a:p>
             <a:r>
               <a:rPr lang="en-US" dirty="0"/>
-              <a:t>זמן: 20:10-21:30
-המודל הוא חלק מהמערכת. אנחנו עדיין אחראים להכין קלט טוב, להגדיר פעולות ולבדוק תנאים.
-בדף אמיתי יש גם טקסט לא מהימן. טקסט באתר יכול לנסות להנחות את המודל (prompt injection), ולכן לא מתייחסים אליו כהרשאה. זה נשאר סיכון גם כשהתשובה היא בחירה מרשימה.
-אתר הדמו בשליטתנו, ויש בו מזהים יציבים. אתר חיצוני מוסיף התחברות, חלונות קופצים, שינויים במבנה, תנאי שימוש ואתגרים נוספים. הדמו מבודד את רעיון הבחירה כדי שנוכל ללמוד אותו.
-אין צורך בהרצאת אבטחה של שעה. לבחור דוגמה אחת: מלון שכותב בדף שהוא עומד בכל הדרישות לא פוטר אותנו מבדיקת השדות.
-מקור: https://docs.typesafe.ai/model-jaggedness/jev-1.13</a:t>
+              <a:t>זמן: 22:30–23:30
+שינויי זמינות מאושרים ממצב המגיש ומסונכרנים לדף בנקודת עצירה. החלטת מודל שנשארה תלויה לא יכולה לבצע לחיצה אחרי Stop או Reset. זמן ההמתנה להחלטה מוגבל ל-30 שניות, ויש מגבלת צעדים. Stop מפסיק המתנה מקומית; אין כאן הבטחה לביטול חיוב אצל ספק מודל שכבר קיבל בקשה.</a:t>
             </a:r>
             <a:endParaRPr lang="en-US" dirty="0"/>
           </a:p>
@@ -1206,7 +1186,7 @@
     </p:spTree>
     <p:extLst>
       <p:ext uri="{BB962C8B-B14F-4D97-AF65-F5344CB8AC3E}">
-        <p14:creationId xmlns:p14="http://schemas.microsoft.com/office/powerpoint/2010/main" val="1024086991"/>
+        <ns2:creationId val="1024086991"/>
       </p:ext>
     </p:extLst>
   </p:cSld>
@@ -1217,7 +1197,7 @@
 </file>
 
 <file path=ppt/notesSlides/notesSlide17.xml><?xml version="1.0" encoding="utf-8"?>
-<p:notes xmlns:a="http://schemas.openxmlformats.org/drawingml/2006/main" xmlns:r="http://schemas.openxmlformats.org/officeDocument/2006/relationships" xmlns:p="http://schemas.openxmlformats.org/presentationml/2006/main">
+<p:notes xmlns:a="http://schemas.openxmlformats.org/drawingml/2006/main" xmlns:ns2="http://schemas.microsoft.com/office/powerpoint/2010/main" xmlns:p="http://schemas.openxmlformats.org/presentationml/2006/main">
   <p:cSld>
     <p:spTree>
       <p:nvGrpSpPr>
@@ -1262,7 +1242,7 @@
           <a:p>
             <a:r>
               <a:rPr lang="en-US" dirty="0"/>
-              <a:t>זמן: 21:30-22:40
+              <a:t>זמן: 23:30–24:30
 הייתי מתחיל ממסך אחד באתר שבשליטתכם. בוחרים משימה, מגדירים פעולות ומחברים בחירה לתוצאה שאפשר לבדוק. למשל, מיון בקשה במערכת פנימית או מעבר לטופס המתאים. אחרי שזה עובד, מרחיבים.
 ערכת ההתחלה בשקף לא דורשת AWS ולא דורשת Jev: כל מודל שמחזיר structured output מספיק כדי להתחיל.
 Jev מעניין כי הוא נותן לנו צורת ממשק אחרת בין מודל לקוד. בפועל צריך למדוד: כמה צעדים הצליחו, האם המשימה הושלמה, ומה הזמן והעלות הכוללים, כולל הכנת הקלט וקריאות נוספות. אין כאן תוצאה שמוכיחה יתרון ביצועים. המטרה היא לצאת עם משהו שאפשר לנסות בצורה מסודרת.
@@ -1298,7 +1278,7 @@
     </p:spTree>
     <p:extLst>
       <p:ext uri="{BB962C8B-B14F-4D97-AF65-F5344CB8AC3E}">
-        <p14:creationId xmlns:p14="http://schemas.microsoft.com/office/powerpoint/2010/main" val="1024086991"/>
+        <ns2:creationId val="1024086991"/>
       </p:ext>
     </p:extLst>
   </p:cSld>
@@ -1309,7 +1289,7 @@
 </file>
 
 <file path=ppt/notesSlides/notesSlide18.xml><?xml version="1.0" encoding="utf-8"?>
-<p:notes xmlns:a="http://schemas.openxmlformats.org/drawingml/2006/main" xmlns:r="http://schemas.openxmlformats.org/officeDocument/2006/relationships" xmlns:p="http://schemas.openxmlformats.org/presentationml/2006/main">
+<p:notes xmlns:a="http://schemas.openxmlformats.org/drawingml/2006/main" xmlns:ns2="http://schemas.microsoft.com/office/powerpoint/2010/main" xmlns:p="http://schemas.openxmlformats.org/presentationml/2006/main">
   <p:cSld>
     <p:spTree>
       <p:nvGrpSpPr>
@@ -1354,12 +1334,8 @@
           <a:p>
             <a:r>
               <a:rPr lang="en-US" dirty="0"/>
-              <a:t>זמן: 22:40-30:00
-עד דקה 25, סיכום במשפט אחד (מופיע בשקף): המודל בוחר מתוך רשימה. הקוד שלכם קובע מה ברשימה, בודק ומבצע.
-להפנות ל-wave-lab כריפו הדוגמאות הכללי (דמו החופשה נמצא ב-demos/vacation-agent, והמצגת עצמה ב-demos/vacation-agent/talk), ולוודא לפני ההרצאה שה-PR מוזג. אם לא, להגיד שהקוד נמצא ב-branch ולא ב-main.
-מכאן שאלות עד דקה 30. אם אין שאלות, לשאול: איפה במוצר שלכם יש מסך עם מספר קטן של פעולות, שהבחירה ביניהן תלויה בהקשר? לקחת דוגמה אחת ולמפות אותה למצב, לאפשרויות ולבדיקה.
-שאלה צפויה: "למה לא פשוט LLM עם enum ב-structured output?" יש שקף נספח מוכן לזה (שקף 20).
-מקור קישור: https://github.com/tomerwave/wave-lab</a:t>
+              <a:t>זמן: 24:30–25:00
+סיימו את הסיפור עד דקה 25. שאלות בדקות 25–30. שקפים 19–21 נספח בלבד, לפי השאלה. לפני מעבר לשאלות אמרו: בחזרה הזאת הבחירות מתוסרטות; מסלולי Jev/AWS קיימים בקוד ולא נבדקו כאן בתשלום.</a:t>
             </a:r>
             <a:endParaRPr lang="en-US" dirty="0"/>
           </a:p>
@@ -1391,7 +1367,7 @@
     </p:spTree>
     <p:extLst>
       <p:ext uri="{BB962C8B-B14F-4D97-AF65-F5344CB8AC3E}">
-        <p14:creationId xmlns:p14="http://schemas.microsoft.com/office/powerpoint/2010/main" val="1024086991"/>
+        <ns2:creationId val="1024086991"/>
       </p:ext>
     </p:extLst>
   </p:cSld>
@@ -1402,7 +1378,7 @@
 </file>
 
 <file path=ppt/notesSlides/notesSlide19.xml><?xml version="1.0" encoding="utf-8"?>
-<p:notes xmlns:a="http://schemas.openxmlformats.org/drawingml/2006/main" xmlns:r="http://schemas.openxmlformats.org/officeDocument/2006/relationships" xmlns:p="http://schemas.openxmlformats.org/presentationml/2006/main">
+<p:notes xmlns:a="http://schemas.openxmlformats.org/drawingml/2006/main" xmlns:ns2="http://schemas.microsoft.com/office/powerpoint/2010/main" xmlns:p="http://schemas.openxmlformats.org/presentationml/2006/main">
   <p:cSld>
     <p:spTree>
       <p:nvGrpSpPr>
@@ -1447,9 +1423,8 @@
           <a:p>
             <a:r>
               <a:rPr lang="en-US" dirty="0"/>
-              <a:t>נספח
-להשתמש רק אם עולה שאלת הארכיטקטורה. המודל ב-Bedrock דרך Strands מנהל את התוכנית. כלי הדפדפן שלנו מפעיל לולאה מקומית עם מגבלת צעדים, ו-Jev לבחירה. הכלי מחזיר סיכום כשתת־המשימה הושלמה, או כשהוא נתקל בשינוי או בכשל. אפשר גם להתחיל עם קריאה ל-LLM בכל צעד. אין פתרון אחד שמתאים לכל אתר. זו חלוקה מוצעת שצריך למדוד.
-מקורות: https://strandsagents.com/docs/user-guide/sdk/ ; https://docs.typesafe.ai/sdk/javascript</a:t>
+              <a:t>זמן: נספח לשאלות, 25:00–30:00
+זה שיקול למוצר עתידי. בדמו המתכנן האופציונלי מפעיל כלי find_hotel פעם אחת בלבד. שינויי קהל מעדכנים את אותו סשן של הלולאה; אין כאן framework שמזמן שוב מתכנן אוטומטית.</a:t>
             </a:r>
             <a:endParaRPr lang="en-US" dirty="0"/>
           </a:p>
@@ -1481,7 +1456,7 @@
     </p:spTree>
     <p:extLst>
       <p:ext uri="{BB962C8B-B14F-4D97-AF65-F5344CB8AC3E}">
-        <p14:creationId xmlns:p14="http://schemas.microsoft.com/office/powerpoint/2010/main" val="1024086991"/>
+        <ns2:creationId val="1024086991"/>
       </p:ext>
     </p:extLst>
   </p:cSld>
@@ -1492,7 +1467,7 @@
 </file>
 
 <file path=ppt/notesSlides/notesSlide2.xml><?xml version="1.0" encoding="utf-8"?>
-<p:notes xmlns:a="http://schemas.openxmlformats.org/drawingml/2006/main" xmlns:r="http://schemas.openxmlformats.org/officeDocument/2006/relationships" xmlns:p="http://schemas.openxmlformats.org/presentationml/2006/main">
+<p:notes xmlns:a="http://schemas.openxmlformats.org/drawingml/2006/main" xmlns:ns2="http://schemas.microsoft.com/office/powerpoint/2010/main" xmlns:p="http://schemas.openxmlformats.org/presentationml/2006/main">
   <p:cSld>
     <p:spTree>
       <p:nvGrpSpPr>
@@ -1537,7 +1512,7 @@
           <a:p>
             <a:r>
               <a:rPr lang="en-US" dirty="0"/>
-              <a:t>זמן: 00:40-01:20
+              <a:t>זמן: 00:40–01:30
 אני תומר, Fractional CTO ויועץ טכנולוגי. בניתי תשתיות דפדפן וניהול סשנים מאומתים בחברה שמאפשרת לסוכנים לעבוד באתרי אינטרנט. הובלתי גם פיתוח בסטארטאפ שעוסק באמינות סוכנים, כולל תיקון תקלות בזמן ריצה. כך שמה שקורה בין ההחלטה ללחיצה מוכר לי מקרוב. מחוץ למחשב אני מטפס ורוקד. גם שם כדאי לדעת מה הצעד הבא.
 ה-YAML הוא עיבוד מקוצר של ה-README האמיתי, עם הניסיון הרלוונטי. אין לציין שמות חברות.
 מקורות: https://tomerwave.com/ ; https://tomerwave.com/about ; https://github.com/tomerwave/tomerwave/blob/main/ReadMe.md</a:t>
@@ -1572,7 +1547,7 @@
     </p:spTree>
     <p:extLst>
       <p:ext uri="{BB962C8B-B14F-4D97-AF65-F5344CB8AC3E}">
-        <p14:creationId xmlns:p14="http://schemas.microsoft.com/office/powerpoint/2010/main" val="1024086991"/>
+        <ns2:creationId val="1024086991"/>
       </p:ext>
     </p:extLst>
   </p:cSld>
@@ -1583,7 +1558,7 @@
 </file>
 
 <file path=ppt/notesSlides/notesSlide20.xml><?xml version="1.0" encoding="utf-8"?>
-<p:notes xmlns:a="http://schemas.openxmlformats.org/drawingml/2006/main" xmlns:r="http://schemas.openxmlformats.org/officeDocument/2006/relationships" xmlns:p="http://schemas.openxmlformats.org/presentationml/2006/main">
+<p:notes xmlns:a="http://schemas.openxmlformats.org/drawingml/2006/main" xmlns:ns2="http://schemas.microsoft.com/office/powerpoint/2010/main" xmlns:p="http://schemas.openxmlformats.org/presentationml/2006/main">
   <p:cSld>
     <p:spTree>
       <p:nvGrpSpPr>
@@ -1662,7 +1637,7 @@
     </p:spTree>
     <p:extLst>
       <p:ext uri="{BB962C8B-B14F-4D97-AF65-F5344CB8AC3E}">
-        <p14:creationId xmlns:p14="http://schemas.microsoft.com/office/powerpoint/2010/main" val="1024086991"/>
+        <ns2:creationId val="1024086991"/>
       </p:ext>
     </p:extLst>
   </p:cSld>
@@ -1673,7 +1648,7 @@
 </file>
 
 <file path=ppt/notesSlides/notesSlide21.xml><?xml version="1.0" encoding="utf-8"?>
-<p:notes xmlns:a="http://schemas.openxmlformats.org/drawingml/2006/main" xmlns:r="http://schemas.openxmlformats.org/officeDocument/2006/relationships" xmlns:p="http://schemas.openxmlformats.org/presentationml/2006/main">
+<p:notes xmlns:a="http://schemas.openxmlformats.org/drawingml/2006/main" xmlns:ns2="http://schemas.microsoft.com/office/powerpoint/2010/main" xmlns:p="http://schemas.openxmlformats.org/presentationml/2006/main">
   <p:cSld>
     <p:spTree>
       <p:nvGrpSpPr>
@@ -1718,18 +1693,8 @@
           <a:p>
             <a:r>
               <a:rPr lang="en-US" dirty="0"/>
-              <a:t>נספח
-מקורות מלאים, נבדקו ב-22 בספטמבר 2026:
-https://typesafe.ai/blog/introducing-system-one-models-and-jev
-https://docs.typesafe.ai/sdk/javascript
-https://docs.typesafe.ai/primitives/choice
-https://docs.typesafe.ai/confidence
-https://docs.typesafe.ai/model-jaggedness/jev-1.13
-https://strandsagents.com/docs/user-guide/sdk/
-https://docs.aws.amazon.com/bedrock-agentcore/latest/devguide/browser-tool.html
-https://tomerwave.com/
-https://github.com/tomerwave/wave-lab
-קוד הדמו המצורף הוא המחשה מקומית מתוסרטת ודוגמת שילוב. חיבור חי ל-Jev, Bedrock ו-AgentCore דורש הגדרה ובדיקה לפני העלייה לבמה.</a:t>
+              <a:t>זמן: נספח לשאלות, 25:00–30:00
+אתר הדמו הבדוי: https://vacation-agent-rehearsal.vercel.app. קוד: github.com/tomerwave/wave-lab, branch feat/vacation-agent-demo. פקודות החזרה ב-talk/rehearsal-guide.md. מקורות המקור נשמרו. אין טענה שכל אינטגרציה חיה אומתה.</a:t>
             </a:r>
             <a:endParaRPr lang="en-US" dirty="0"/>
           </a:p>
@@ -1761,7 +1726,7 @@
     </p:spTree>
     <p:extLst>
       <p:ext uri="{BB962C8B-B14F-4D97-AF65-F5344CB8AC3E}">
-        <p14:creationId xmlns:p14="http://schemas.microsoft.com/office/powerpoint/2010/main" val="1024086991"/>
+        <ns2:creationId val="1024086991"/>
       </p:ext>
     </p:extLst>
   </p:cSld>
@@ -1772,7 +1737,7 @@
 </file>
 
 <file path=ppt/notesSlides/notesSlide3.xml><?xml version="1.0" encoding="utf-8"?>
-<p:notes xmlns:a="http://schemas.openxmlformats.org/drawingml/2006/main" xmlns:r="http://schemas.openxmlformats.org/officeDocument/2006/relationships" xmlns:p="http://schemas.openxmlformats.org/presentationml/2006/main">
+<p:notes xmlns:a="http://schemas.openxmlformats.org/drawingml/2006/main" xmlns:ns2="http://schemas.microsoft.com/office/powerpoint/2010/main" xmlns:p="http://schemas.openxmlformats.org/presentationml/2006/main">
   <p:cSld>
     <p:spTree>
       <p:nvGrpSpPr>
@@ -1817,7 +1782,7 @@
           <a:p>
             <a:r>
               <a:rPr lang="en-US" dirty="0"/>
-              <a:t>זמן: 01:20-02:10
+              <a:t>זמן: 01:30–02:30
 המשימה: שלושה לילות, עד 600 אירו לכל השהייה, ומלון נגיש. הנגישות היא תנאי חובה, לא העדפה שאפשר לוותר עליה כי הנוף יפה. התאריכים קבועים, כדי שנתמקד בבחירת הפעולה.
 אפשר לבקש הרמת ידיים: מי כבר בנה סוכן או השתמש בכלי לאוטומציה של דפדפן? אין צורך בהיכרות מוקדמת.
 במה: לפתוח את אתר הדמו בלשונית מוכנה. הסכומים בדויים. החישוב נעשה בקוד, לא במודל.</a:t>
@@ -1852,7 +1817,7 @@
     </p:spTree>
     <p:extLst>
       <p:ext uri="{BB962C8B-B14F-4D97-AF65-F5344CB8AC3E}">
-        <p14:creationId xmlns:p14="http://schemas.microsoft.com/office/powerpoint/2010/main" val="1024086991"/>
+        <ns2:creationId val="1024086991"/>
       </p:ext>
     </p:extLst>
   </p:cSld>
@@ -1863,7 +1828,7 @@
 </file>
 
 <file path=ppt/notesSlides/notesSlide4.xml><?xml version="1.0" encoding="utf-8"?>
-<p:notes xmlns:a="http://schemas.openxmlformats.org/drawingml/2006/main" xmlns:r="http://schemas.openxmlformats.org/officeDocument/2006/relationships" xmlns:p="http://schemas.openxmlformats.org/presentationml/2006/main">
+<p:notes xmlns:a="http://schemas.openxmlformats.org/drawingml/2006/main" xmlns:ns2="http://schemas.microsoft.com/office/powerpoint/2010/main" xmlns:p="http://schemas.openxmlformats.org/presentationml/2006/main">
   <p:cSld>
     <p:spTree>
       <p:nvGrpSpPr>
@@ -1908,11 +1873,8 @@
           <a:p>
             <a:r>
               <a:rPr lang="en-US" dirty="0"/>
-              <a:t>זמן: 02:10-03:40
-במה: להציג את הדפדפן ולפתוח את מלון A במחיר 520 אירו. להסביר רק את מה שרואים: תוצאות, בחירה, דף פרטים. לא להסביר עדיין את הארכיטקטורה.
-לשאול: מה הייתם מצפים שהסוכן יבדוק לפני שהוא ממשיך? לקחת תשובה אחת. להצביע על מחיר, זמינות ונגישות.
-פקודות: npm run demo:vacation -- happy / sold-out / budget-drop (עם HEADED=1 ו-SLOW_MO_MS=600 כדי שהקהל יראה את הדפדפן). מסלול מקומי: לבחור מצב המחשה מתוסרטת ולהשאיר את הסימון גלוי. מסלול חי, אחרי חיבור: להפעיל את הכלי ולשמור trace. אם הבחירה מתוסרטת, לא לומר ש-Jev בחר.
-אם האתר לא עולה: להשתמש בשקף המשימה ולהקריא את המצב: מלון A עולה 520 אירו, נגיש וזמין. לא לבזבז זמן במה על התקנה.</a:t>
+              <a:t>זמן: 02:30–04:00
+הפעילו מראש מהטרמינל: HEADED=1 npm run demo:vacation -- happy --interactive --site-url https://vacation-agent-rehearsal.vercel.app. האתר נראה כמו אתר חופשות רגיל. כל הפקודות וה-trace בטרמינל, בלי כפתורי מגיש באתר. אמרו בקול: הבחירות מתוסרטות בחזרה הזאת, בלי קריאות Jev או AWS. next ראשון בוחר open_hotel_A; next שני לוחץ ונשאר באותו דפדפן.</a:t>
             </a:r>
             <a:endParaRPr lang="en-US" dirty="0"/>
           </a:p>
@@ -1944,7 +1906,7 @@
     </p:spTree>
     <p:extLst>
       <p:ext uri="{BB962C8B-B14F-4D97-AF65-F5344CB8AC3E}">
-        <p14:creationId xmlns:p14="http://schemas.microsoft.com/office/powerpoint/2010/main" val="1024086991"/>
+        <ns2:creationId val="1024086991"/>
       </p:ext>
     </p:extLst>
   </p:cSld>
@@ -1955,7 +1917,7 @@
 </file>
 
 <file path=ppt/notesSlides/notesSlide5.xml><?xml version="1.0" encoding="utf-8"?>
-<p:notes xmlns:a="http://schemas.openxmlformats.org/drawingml/2006/main" xmlns:r="http://schemas.openxmlformats.org/officeDocument/2006/relationships" xmlns:p="http://schemas.openxmlformats.org/presentationml/2006/main">
+<p:notes xmlns:a="http://schemas.openxmlformats.org/drawingml/2006/main" xmlns:ns2="http://schemas.microsoft.com/office/powerpoint/2010/main" xmlns:p="http://schemas.openxmlformats.org/presentationml/2006/main">
   <p:cSld>
     <p:spTree>
       <p:nvGrpSpPr>
@@ -2000,11 +1962,8 @@
           <a:p>
             <a:r>
               <a:rPr lang="en-US" dirty="0"/>
-              <a:t>זמן: 03:40-05:10
-לבקש הצבעה בין שתי אפשרויות שהכנו מראש: המלון התמלא, או שהתקציב ירד ל-500 אירו. לקחת את רוב הקולות ולהפעיל שינוי אחד. אם אין רוב ברור, לבחור ב"המלון התמלא". לא לפתוח דיון על כל יעד אפשרי בעולם. לתת לריצה להגיב, ולעצור ברגע שבו צריך לבחור מחדש.
-הבדיחה: באינטרנט, החדר האחרון פנוי בדיוק עד שאתם מוציאים את כרטיס האשראי.
-לשמור על מסלול ברור: אם A מלא, C נגיש ועולה 590. אם התקציב ירד ל-500, אין אפשרות שעומדת גם בתקציב וגם בנגישות. שתי התוצאות מלמדות משהו, ונראה את שתיהן בהמשך (שקפים 14 ו-15).
-איור מקורי שנוצר עבור ההרצאה, לא תיעוד מוצר.</a:t>
+              <a:t>זמן: 04:00–06:00
+next שלישי משאיר את אותה ריצה בהשהיה ב-before_click עם select_hotel. עוד אין לחיצה. הקהל בוחר שינוי, ואתם מקלידים בטרמינל sold-out A או budget 500. השינוי נכנס לתור ומיושם בנקודת העצירה. next או run יראו world_changed וגרסת החלטה ישנה מול גרסת עולם חדשה. אין הפעלה מחדש כדי לשנות את התנאים. אפשר להשאיר את הריצה מושהית בזמן ההסבר ולחזור אליה בשקף 14.</a:t>
             </a:r>
             <a:endParaRPr lang="en-US" dirty="0"/>
           </a:p>
@@ -2036,7 +1995,7 @@
     </p:spTree>
     <p:extLst>
       <p:ext uri="{BB962C8B-B14F-4D97-AF65-F5344CB8AC3E}">
-        <p14:creationId xmlns:p14="http://schemas.microsoft.com/office/powerpoint/2010/main" val="1024086991"/>
+        <ns2:creationId val="1024086991"/>
       </p:ext>
     </p:extLst>
   </p:cSld>
@@ -2047,7 +2006,7 @@
 </file>
 
 <file path=ppt/notesSlides/notesSlide6.xml><?xml version="1.0" encoding="utf-8"?>
-<p:notes xmlns:a="http://schemas.openxmlformats.org/drawingml/2006/main" xmlns:r="http://schemas.openxmlformats.org/officeDocument/2006/relationships" xmlns:p="http://schemas.openxmlformats.org/presentationml/2006/main">
+<p:notes xmlns:a="http://schemas.openxmlformats.org/drawingml/2006/main" xmlns:ns2="http://schemas.microsoft.com/office/powerpoint/2010/main" xmlns:p="http://schemas.openxmlformats.org/presentationml/2006/main">
   <p:cSld>
     <p:spTree>
       <p:nvGrpSpPr>
@@ -2092,15 +2051,8 @@
           <a:p>
             <a:r>
               <a:rPr lang="en-US" dirty="0"/>
-              <a:t>זמן: 05:10-06:50
-סוכן הוא תוכנה שמנסה להשיג מטרה, מקבלת מידע ובוחרת מה לעשות בהמשך. לפעמים הפעולה היא קריאה לכלי, ולפעמים שאלה לאדם.
-אם כתבתי בקוד "תמיד לפתוח את המלון הראשון ואז להמשיך", זה מסלול קבוע. גם קוד רגיל יכול להגיב לשינוי עם if. בסוכן שלנו, המודל מקבל את המטרה ואת המצב החדש ובוחר פעולה מתוך האפשרויות. גם הסוכן הזה מכיל הרבה קוד קבוע. אנחנו לא זורקים את ה-if לפח.
-לג'וניורים: אין כאן קסם של מחשבים שלוחצים לבד. החידוש הוא מי בוחר את הפעולה, ולפי איזה מידע.
-מקור: https://strandsagents.com/docs/user-guide/sdk/
-הלולאה (החצי השמאלי של השקף): לעבור על הלולאה מהפינה הימנית העליונה: קוראים את המצב, בוחרים פעולה, מפעילים כלי ובודקים את התוצאה. בסיבוב הבא הקלט כבר השתנה.
-בדמו (העמודה הימנית): קוראים שהמלון מלא, בוחרים לחזור לתוצאות, מבצעים וקוראים את התוצאות החדשות. לולאה בלי בדיקת תוצאה יכולה ללחוץ שוב ושוב על משהו שכבר לא קיים. כולנו מכירים את זה מהמדפסת.
-להדגיש: הבחירה יכולה להיות של המודל, אבל איסוף המידע, ההרשאות ובדיקת התוצאה באחריות הקוד. זה תרשים מפושט של המימוש המוצע, לצורך הסבר.
-משקף 7 והלאה, המפה הקטנה בתחתית השקף מראה באיזה רכיב אנחנו נמצאים.</a:t>
+              <a:t>זמן: 06:00–07:30
+לולאה שמקבלת החלטות ממודל היא מסלול הסוכן. במצב החזרה הבוחר מתוסרט ומסומן כך. מנגנון התצפית, ההשהיה, הבדיקה והלחיצה זהה בשני המסלולים. אל תציגו בחירה מתוסרטת כאילו Jev החליט אותה.</a:t>
             </a:r>
             <a:endParaRPr lang="en-US" dirty="0"/>
           </a:p>
@@ -2132,7 +2084,7 @@
     </p:spTree>
     <p:extLst>
       <p:ext uri="{BB962C8B-B14F-4D97-AF65-F5344CB8AC3E}">
-        <p14:creationId xmlns:p14="http://schemas.microsoft.com/office/powerpoint/2010/main" val="1024086991"/>
+        <ns2:creationId val="1024086991"/>
       </p:ext>
     </p:extLst>
   </p:cSld>
@@ -2143,7 +2095,7 @@
 </file>
 
 <file path=ppt/notesSlides/notesSlide7.xml><?xml version="1.0" encoding="utf-8"?>
-<p:notes xmlns:a="http://schemas.openxmlformats.org/drawingml/2006/main" xmlns:r="http://schemas.openxmlformats.org/officeDocument/2006/relationships" xmlns:p="http://schemas.openxmlformats.org/presentationml/2006/main">
+<p:notes xmlns:a="http://schemas.openxmlformats.org/drawingml/2006/main" xmlns:ns2="http://schemas.microsoft.com/office/powerpoint/2010/main" xmlns:p="http://schemas.openxmlformats.org/presentationml/2006/main">
   <p:cSld>
     <p:spTree>
       <p:nvGrpSpPr>
@@ -2188,7 +2140,7 @@
           <a:p>
             <a:r>
               <a:rPr lang="en-US" dirty="0"/>
-              <a:t>זמן: 06:50-08:00
+              <a:t>זמן: 07:30–09:00
 כלי הוא פשוט פונקציה שהסוכן יכול לבקש להפעיל. למשל, פתיחת דף מלון. יש לה שם, קלט מוגדר ותוצאה. בדפדפן, הפונקציה יכולה להשתמש ב-Playwright, ספרייה שמאפשרת לקוד ללחוץ, להקליד ולקרוא את הדף. המודל מחזיר החלטה, והקוד מתרגם אותה לביצוע. להגיד במפורש: המודל לא מריץ את הפונקציה ולא כותב selectors.
 השקף מראה את מה שהדמו ב-wave-lab מדפיס: Jev מחזיר את המזהה open_hotel_C, הקוד מוצא אותו ב-registry, לוחץ עם Playwright וקורא את המצב החדש. התוצאה בדויה.
 מקורות: https://strandsagents.com/docs/user-guide/sdk/ ; https://docs.aws.amazon.com/bedrock-agentcore/latest/devguide/browser-tool.html</a:t>
@@ -2223,7 +2175,7 @@
     </p:spTree>
     <p:extLst>
       <p:ext uri="{BB962C8B-B14F-4D97-AF65-F5344CB8AC3E}">
-        <p14:creationId xmlns:p14="http://schemas.microsoft.com/office/powerpoint/2010/main" val="1024086991"/>
+        <ns2:creationId val="1024086991"/>
       </p:ext>
     </p:extLst>
   </p:cSld>
@@ -2234,7 +2186,7 @@
 </file>
 
 <file path=ppt/notesSlides/notesSlide8.xml><?xml version="1.0" encoding="utf-8"?>
-<p:notes xmlns:a="http://schemas.openxmlformats.org/drawingml/2006/main" xmlns:r="http://schemas.openxmlformats.org/officeDocument/2006/relationships" xmlns:p="http://schemas.openxmlformats.org/presentationml/2006/main">
+<p:notes xmlns:a="http://schemas.openxmlformats.org/drawingml/2006/main" xmlns:ns2="http://schemas.microsoft.com/office/powerpoint/2010/main" xmlns:p="http://schemas.openxmlformats.org/presentationml/2006/main">
   <p:cSld>
     <p:spTree>
       <p:nvGrpSpPr>
@@ -2279,12 +2231,8 @@
           <a:p>
             <a:r>
               <a:rPr lang="en-US" dirty="0"/>
-              <a:t>זמן: 08:00-09:30
-Jev הוא מודל של TypeSafe AI. היום נתמקד ב-Choice: נותנים מצב, שאלה ואפשרויות, ומקבלים בחירה. בדמו שלנו השאלה היא איזו פעולה זמינה תקדם את תת־המשימה.
-מה שמעניין כאן: מודל שתוכנן להחזיר החלטה במבנה מוגדר, שאפשר לחבר ישירות לקוד. הוא לא צריך לנסח פסקה כדי להגיד "חזור לתוצאות". למי שמכיר structured output: זה קרוב לרעיון של enum, רק שהמודל נבנה סביב זה.
-זה לא מבטיח שהבחירה נכונה, וזה לא מוכיח שהדמו שלנו מהיר או זול יותר. אנחנו בוחנים יכולת חדשה דרך דוגמה שקל להבין.
-הספק מציג גם דוגמאות כמו ניווט בוויקיפדיה, עם בחירה בין קישורים. אנחנו לוקחים את העיקרון לאתר החופשות המבוקר שלנו.
-מקורות: https://typesafe.ai/blog/introducing-system-one-models-and-jev ; https://docs.typesafe.ai/primitives/choice</a:t>
+              <a:t>זמן: 09:00–10:00
+המטרה והתנאים נקבעים בקוד ובידי המגיש. Jev בוחר מזהה פעולה מתוך האפשרויות. Strands הוא מסלול מתכנן אופציונלי, לא תנאי להפעלת הדמו. אין ל-Jev או למתכנן כלי לממשק המגיש, לשינוי תקציב או לתשלום.</a:t>
             </a:r>
             <a:endParaRPr lang="en-US" dirty="0"/>
           </a:p>
@@ -2316,7 +2264,7 @@
     </p:spTree>
     <p:extLst>
       <p:ext uri="{BB962C8B-B14F-4D97-AF65-F5344CB8AC3E}">
-        <p14:creationId xmlns:p14="http://schemas.microsoft.com/office/powerpoint/2010/main" val="1024086991"/>
+        <ns2:creationId val="1024086991"/>
       </p:ext>
     </p:extLst>
   </p:cSld>
@@ -2327,7 +2275,7 @@
 </file>
 
 <file path=ppt/notesSlides/notesSlide9.xml><?xml version="1.0" encoding="utf-8"?>
-<p:notes xmlns:a="http://schemas.openxmlformats.org/drawingml/2006/main" xmlns:r="http://schemas.openxmlformats.org/officeDocument/2006/relationships" xmlns:p="http://schemas.openxmlformats.org/presentationml/2006/main">
+<p:notes xmlns:a="http://schemas.openxmlformats.org/drawingml/2006/main" xmlns:ns2="http://schemas.microsoft.com/office/powerpoint/2010/main" xmlns:p="http://schemas.openxmlformats.org/presentationml/2006/main">
   <p:cSld>
     <p:spTree>
       <p:nvGrpSpPr>
@@ -2372,7 +2320,7 @@
           <a:p>
             <a:r>
               <a:rPr lang="en-US" dirty="0"/>
-              <a:t>זמן: 09:30-11:20
+              <a:t>זמן: 10:00–11:30
 רגע חי (כ-20 שניות): לעבור לדפדפן ולהראות את דף מלון A לצד המצב המתומצת שהקוד בנה ממנו. אם אין חיבור, השקף עצמו מראה את שני הצדדים.
 DOM הוא המבנה של דף האינטרנט: כותרות, כפתורים, שדות ותוכן. לא צריך לשלוח את כל האתר. הקוד שלנו קורא את המידע הרלוונטי ומכין תיאור קצר. לצדו יש רשימת פעולות שבאמת אפשר לבצע כרגע. שימו לב: כפתור ההזמנה לא מופיע ברשימה, כי המלון מלא. Jev מקבל כאן טקסט מובנה, לא צילום מסך.
 החלק ההנדסי החשוב נמצא לפני הקריאה למודל: איך משאירים רק את המידע השימושי, איך ממפים פעולה לאלמנט, ואיך לא מציעים כפתור שכבר נעלם. באתר הדמו יש לנו מזהים יציבים (בסגנון data-testid). באתר חיצוני זה קשה יותר ודורש טיפול נפרד.
@@ -2409,7 +2357,7 @@
     </p:spTree>
     <p:extLst>
       <p:ext uri="{BB962C8B-B14F-4D97-AF65-F5344CB8AC3E}">
-        <p14:creationId xmlns:p14="http://schemas.microsoft.com/office/powerpoint/2010/main" val="1024086991"/>
+        <ns2:creationId val="1024086991"/>
       </p:ext>
     </p:extLst>
   </p:cSld>
@@ -6601,7 +6549,7 @@
 </file>
 
 <file path=ppt/slides/slide12.xml><?xml version="1.0" encoding="utf-8"?>
-<p:sld xmlns:a="http://schemas.openxmlformats.org/drawingml/2006/main" xmlns:r="http://schemas.openxmlformats.org/officeDocument/2006/relationships" xmlns:p="http://schemas.openxmlformats.org/presentationml/2006/main">
+<p:sld xmlns:a="http://schemas.openxmlformats.org/drawingml/2006/main" xmlns:p="http://schemas.openxmlformats.org/presentationml/2006/main" xmlns:r="http://schemas.openxmlformats.org/officeDocument/2006/relationships">
   <p:cSld name="Slide 12">
     <p:bg>
       <p:bgPr>
@@ -7790,7 +7738,7 @@
                 <a:ea typeface="Instrument Sans" pitchFamily="34" charset="-122"/>
                 <a:cs typeface="Assistant" pitchFamily="34" charset="-120"/>
               </a:rPr>
-              <a:t>המצב החדש חוזר ל-Jev. כשתת־המשימה מסתיימת, חוזרים למתכנן.</a:t>
+              <a:t>המצב החדש חוזר ל-Jev. בדמו: find_hotel אחד, בלי חזרה אוטומטית למתכנן.</a:t>
             </a:r>
             <a:endParaRPr lang="he-IL" sz="1300" dirty="0"/>
           </a:p>
@@ -7961,7 +7909,7 @@
                 <a:ea typeface="Instrument Sans" pitchFamily="34" charset="-122"/>
                 <a:cs typeface="Assistant" pitchFamily="34" charset="-120"/>
               </a:rPr>
-              <a:t>להתחלה מספיק Playwright מקומי, בלי AWS.</a:t>
+              <a:t>המסלול החי אופציונלי ולא נבדק כאן</a:t>
             </a:r>
             <a:endParaRPr lang="he-IL" sz="1400" dirty="0"/>
           </a:p>
@@ -7976,7 +7924,7 @@
 </file>
 
 <file path=ppt/slides/slide13.xml><?xml version="1.0" encoding="utf-8"?>
-<p:sld xmlns:a="http://schemas.openxmlformats.org/drawingml/2006/main" xmlns:r="http://schemas.openxmlformats.org/officeDocument/2006/relationships" xmlns:p="http://schemas.openxmlformats.org/presentationml/2006/main">
+<p:sld xmlns:a="http://schemas.openxmlformats.org/drawingml/2006/main" xmlns:p="http://schemas.openxmlformats.org/presentationml/2006/main" xmlns:r="http://schemas.openxmlformats.org/officeDocument/2006/relationships">
   <p:cSld name="Slide 13">
     <p:bg>
       <p:bgPr>
@@ -8322,7 +8270,7 @@
                 <a:ea typeface="JetBrains Mono" pitchFamily="34" charset="-122"/>
                 <a:cs typeface="JetBrains Mono" pitchFamily="34" charset="-120"/>
               </a:rPr>
-              <a:t>const</a:t>
+              <a:t>await presenter.checkpoint("before_click", id);</a:t>
             </a:r>
             <a:r>
               <a:rPr lang="en-US" sz="1350" dirty="0">
@@ -8333,7 +8281,7 @@
                 <a:ea typeface="JetBrains Mono" pitchFamily="34" charset="-122"/>
                 <a:cs typeface="JetBrains Mono" pitchFamily="34" charset="-120"/>
               </a:rPr>
-              <a:t> </a:t>
+              <a:t/>
             </a:r>
             <a:r>
               <a:rPr lang="en-US" sz="1350" dirty="0">
@@ -8344,7 +8292,7 @@
                 <a:ea typeface="JetBrains Mono" pitchFamily="34" charset="-122"/>
                 <a:cs typeface="JetBrains Mono" pitchFamily="34" charset="-120"/>
               </a:rPr>
-              <a:t>action</a:t>
+              <a:t/>
             </a:r>
             <a:r>
               <a:rPr lang="en-US" sz="1350" dirty="0">
@@ -8355,7 +8303,7 @@
                 <a:ea typeface="JetBrains Mono" pitchFamily="34" charset="-122"/>
                 <a:cs typeface="JetBrains Mono" pitchFamily="34" charset="-120"/>
               </a:rPr>
-              <a:t> </a:t>
+              <a:t/>
             </a:r>
             <a:r>
               <a:rPr lang="en-US" sz="1350" dirty="0">
@@ -8366,7 +8314,7 @@
                 <a:ea typeface="JetBrains Mono" pitchFamily="34" charset="-122"/>
                 <a:cs typeface="JetBrains Mono" pitchFamily="34" charset="-120"/>
               </a:rPr>
-              <a:t>=</a:t>
+              <a:t/>
             </a:r>
             <a:r>
               <a:rPr lang="en-US" sz="1350" dirty="0">
@@ -8377,7 +8325,7 @@
                 <a:ea typeface="JetBrains Mono" pitchFamily="34" charset="-122"/>
                 <a:cs typeface="JetBrains Mono" pitchFamily="34" charset="-120"/>
               </a:rPr>
-              <a:t> </a:t>
+              <a:t/>
             </a:r>
             <a:r>
               <a:rPr lang="en-US" sz="1350" dirty="0">
@@ -8388,7 +8336,7 @@
                 <a:ea typeface="JetBrains Mono" pitchFamily="34" charset="-122"/>
                 <a:cs typeface="JetBrains Mono" pitchFamily="34" charset="-120"/>
               </a:rPr>
-              <a:t>registry</a:t>
+              <a:t/>
             </a:r>
             <a:r>
               <a:rPr lang="en-US" sz="1350" dirty="0">
@@ -8399,7 +8347,7 @@
                 <a:ea typeface="JetBrains Mono" pitchFamily="34" charset="-122"/>
                 <a:cs typeface="JetBrains Mono" pitchFamily="34" charset="-120"/>
               </a:rPr>
-              <a:t>.</a:t>
+              <a:t/>
             </a:r>
             <a:r>
               <a:rPr lang="en-US" sz="1350" dirty="0">
@@ -8410,7 +8358,7 @@
                 <a:ea typeface="JetBrains Mono" pitchFamily="34" charset="-122"/>
                 <a:cs typeface="JetBrains Mono" pitchFamily="34" charset="-120"/>
               </a:rPr>
-              <a:t>get</a:t>
+              <a:t/>
             </a:r>
             <a:r>
               <a:rPr lang="en-US" sz="1350" dirty="0">
@@ -8421,7 +8369,7 @@
                 <a:ea typeface="JetBrains Mono" pitchFamily="34" charset="-122"/>
                 <a:cs typeface="JetBrains Mono" pitchFamily="34" charset="-120"/>
               </a:rPr>
-              <a:t>(</a:t>
+              <a:t/>
             </a:r>
             <a:r>
               <a:rPr lang="en-US" sz="1350" dirty="0">
@@ -8432,7 +8380,7 @@
                 <a:ea typeface="JetBrains Mono" pitchFamily="34" charset="-122"/>
                 <a:cs typeface="JetBrains Mono" pitchFamily="34" charset="-120"/>
               </a:rPr>
-              <a:t>id</a:t>
+              <a:t/>
             </a:r>
             <a:r>
               <a:rPr lang="en-US" sz="1350" dirty="0">
@@ -8443,7 +8391,7 @@
                 <a:ea typeface="JetBrains Mono" pitchFamily="34" charset="-122"/>
                 <a:cs typeface="JetBrains Mono" pitchFamily="34" charset="-120"/>
               </a:rPr>
-              <a:t>);</a:t>
+              <a:t/>
             </a:r>
             <a:endParaRPr lang="en-US" sz="1350" dirty="0"/>
           </a:p>
@@ -8541,7 +8489,7 @@
                 <a:ea typeface="JetBrains Mono" pitchFamily="34" charset="-122"/>
                 <a:cs typeface="JetBrains Mono" pitchFamily="34" charset="-120"/>
               </a:rPr>
-              <a:t>if</a:t>
+              <a:t>if (decisionRevision !== presenter.revision) return;</a:t>
             </a:r>
             <a:r>
               <a:rPr lang="en-US" sz="1350" dirty="0">
@@ -8552,7 +8500,7 @@
                 <a:ea typeface="JetBrains Mono" pitchFamily="34" charset="-122"/>
                 <a:cs typeface="JetBrains Mono" pitchFamily="34" charset="-120"/>
               </a:rPr>
-              <a:t> </a:t>
+              <a:t/>
             </a:r>
             <a:r>
               <a:rPr lang="en-US" sz="1350" dirty="0">
@@ -8563,7 +8511,7 @@
                 <a:ea typeface="JetBrains Mono" pitchFamily="34" charset="-122"/>
                 <a:cs typeface="JetBrains Mono" pitchFamily="34" charset="-120"/>
               </a:rPr>
-              <a:t>(!</a:t>
+              <a:t/>
             </a:r>
             <a:r>
               <a:rPr lang="en-US" sz="1350" dirty="0">
@@ -8574,7 +8522,7 @@
                 <a:ea typeface="JetBrains Mono" pitchFamily="34" charset="-122"/>
                 <a:cs typeface="JetBrains Mono" pitchFamily="34" charset="-120"/>
               </a:rPr>
-              <a:t>action</a:t>
+              <a:t/>
             </a:r>
             <a:r>
               <a:rPr lang="en-US" sz="1350" dirty="0">
@@ -8585,7 +8533,7 @@
                 <a:ea typeface="JetBrains Mono" pitchFamily="34" charset="-122"/>
                 <a:cs typeface="JetBrains Mono" pitchFamily="34" charset="-120"/>
               </a:rPr>
-              <a:t>)</a:t>
+              <a:t/>
             </a:r>
             <a:r>
               <a:rPr lang="en-US" sz="1350" dirty="0">
@@ -8596,7 +8544,7 @@
                 <a:ea typeface="JetBrains Mono" pitchFamily="34" charset="-122"/>
                 <a:cs typeface="JetBrains Mono" pitchFamily="34" charset="-120"/>
               </a:rPr>
-              <a:t> </a:t>
+              <a:t/>
             </a:r>
             <a:r>
               <a:rPr lang="en-US" sz="1350" dirty="0">
@@ -8607,7 +8555,7 @@
                 <a:ea typeface="JetBrains Mono" pitchFamily="34" charset="-122"/>
                 <a:cs typeface="JetBrains Mono" pitchFamily="34" charset="-120"/>
               </a:rPr>
-              <a:t>return</a:t>
+              <a:t/>
             </a:r>
             <a:r>
               <a:rPr lang="en-US" sz="1350" dirty="0">
@@ -8618,7 +8566,7 @@
                 <a:ea typeface="JetBrains Mono" pitchFamily="34" charset="-122"/>
                 <a:cs typeface="JetBrains Mono" pitchFamily="34" charset="-120"/>
               </a:rPr>
-              <a:t> </a:t>
+              <a:t/>
             </a:r>
             <a:r>
               <a:rPr lang="en-US" sz="1350" dirty="0">
@@ -8629,7 +8577,7 @@
                 <a:ea typeface="JetBrains Mono" pitchFamily="34" charset="-122"/>
                 <a:cs typeface="JetBrains Mono" pitchFamily="34" charset="-120"/>
               </a:rPr>
-              <a:t>replan</a:t>
+              <a:t/>
             </a:r>
             <a:r>
               <a:rPr lang="en-US" sz="1350" dirty="0">
@@ -8640,7 +8588,7 @@
                 <a:ea typeface="JetBrains Mono" pitchFamily="34" charset="-122"/>
                 <a:cs typeface="JetBrains Mono" pitchFamily="34" charset="-120"/>
               </a:rPr>
-              <a:t>(</a:t>
+              <a:t/>
             </a:r>
             <a:r>
               <a:rPr lang="en-US" sz="1350" dirty="0">
@@ -8651,7 +8599,7 @@
                 <a:ea typeface="JetBrains Mono" pitchFamily="34" charset="-122"/>
                 <a:cs typeface="JetBrains Mono" pitchFamily="34" charset="-120"/>
               </a:rPr>
-              <a:t>"unknown_action"</a:t>
+              <a:t/>
             </a:r>
             <a:r>
               <a:rPr lang="en-US" sz="1350" dirty="0">
@@ -8662,7 +8610,7 @@
                 <a:ea typeface="JetBrains Mono" pitchFamily="34" charset="-122"/>
                 <a:cs typeface="JetBrains Mono" pitchFamily="34" charset="-120"/>
               </a:rPr>
-              <a:t>);</a:t>
+              <a:t/>
             </a:r>
             <a:endParaRPr lang="en-US" sz="1350" dirty="0"/>
           </a:p>
@@ -8779,7 +8727,7 @@
                 <a:ea typeface="JetBrains Mono" pitchFamily="34" charset="-122"/>
                 <a:cs typeface="JetBrains Mono" pitchFamily="34" charset="-120"/>
               </a:rPr>
-              <a:t>const</a:t>
+              <a:t>const fresh = await readState(browser);</a:t>
             </a:r>
             <a:r>
               <a:rPr lang="en-US" sz="1350" dirty="0">
@@ -8790,7 +8738,7 @@
                 <a:ea typeface="JetBrains Mono" pitchFamily="34" charset="-122"/>
                 <a:cs typeface="JetBrains Mono" pitchFamily="34" charset="-120"/>
               </a:rPr>
-              <a:t> </a:t>
+              <a:t/>
             </a:r>
             <a:r>
               <a:rPr lang="en-US" sz="1350" dirty="0">
@@ -8801,7 +8749,7 @@
                 <a:ea typeface="JetBrains Mono" pitchFamily="34" charset="-122"/>
                 <a:cs typeface="JetBrains Mono" pitchFamily="34" charset="-120"/>
               </a:rPr>
-              <a:t>fresh</a:t>
+              <a:t/>
             </a:r>
             <a:r>
               <a:rPr lang="en-US" sz="1350" dirty="0">
@@ -8812,7 +8760,7 @@
                 <a:ea typeface="JetBrains Mono" pitchFamily="34" charset="-122"/>
                 <a:cs typeface="JetBrains Mono" pitchFamily="34" charset="-120"/>
               </a:rPr>
-              <a:t> </a:t>
+              <a:t/>
             </a:r>
             <a:r>
               <a:rPr lang="en-US" sz="1350" dirty="0">
@@ -8823,7 +8771,7 @@
                 <a:ea typeface="JetBrains Mono" pitchFamily="34" charset="-122"/>
                 <a:cs typeface="JetBrains Mono" pitchFamily="34" charset="-120"/>
               </a:rPr>
-              <a:t>=</a:t>
+              <a:t/>
             </a:r>
             <a:r>
               <a:rPr lang="en-US" sz="1350" dirty="0">
@@ -8834,7 +8782,7 @@
                 <a:ea typeface="JetBrains Mono" pitchFamily="34" charset="-122"/>
                 <a:cs typeface="JetBrains Mono" pitchFamily="34" charset="-120"/>
               </a:rPr>
-              <a:t> </a:t>
+              <a:t/>
             </a:r>
             <a:r>
               <a:rPr lang="en-US" sz="1350" dirty="0">
@@ -8845,7 +8793,7 @@
                 <a:ea typeface="JetBrains Mono" pitchFamily="34" charset="-122"/>
                 <a:cs typeface="JetBrains Mono" pitchFamily="34" charset="-120"/>
               </a:rPr>
-              <a:t>await</a:t>
+              <a:t/>
             </a:r>
             <a:r>
               <a:rPr lang="en-US" sz="1350" dirty="0">
@@ -8856,7 +8804,7 @@
                 <a:ea typeface="JetBrains Mono" pitchFamily="34" charset="-122"/>
                 <a:cs typeface="JetBrains Mono" pitchFamily="34" charset="-120"/>
               </a:rPr>
-              <a:t> </a:t>
+              <a:t/>
             </a:r>
             <a:r>
               <a:rPr lang="en-US" sz="1350" dirty="0">
@@ -8867,7 +8815,7 @@
                 <a:ea typeface="JetBrains Mono" pitchFamily="34" charset="-122"/>
                 <a:cs typeface="JetBrains Mono" pitchFamily="34" charset="-120"/>
               </a:rPr>
-              <a:t>readState</a:t>
+              <a:t/>
             </a:r>
             <a:r>
               <a:rPr lang="en-US" sz="1350" dirty="0">
@@ -8878,7 +8826,7 @@
                 <a:ea typeface="JetBrains Mono" pitchFamily="34" charset="-122"/>
                 <a:cs typeface="JetBrains Mono" pitchFamily="34" charset="-120"/>
               </a:rPr>
-              <a:t>(</a:t>
+              <a:t/>
             </a:r>
             <a:r>
               <a:rPr lang="en-US" sz="1350" dirty="0">
@@ -8889,7 +8837,7 @@
                 <a:ea typeface="JetBrains Mono" pitchFamily="34" charset="-122"/>
                 <a:cs typeface="JetBrains Mono" pitchFamily="34" charset="-120"/>
               </a:rPr>
-              <a:t>browser</a:t>
+              <a:t/>
             </a:r>
             <a:r>
               <a:rPr lang="en-US" sz="1350" dirty="0">
@@ -8900,7 +8848,7 @@
                 <a:ea typeface="JetBrains Mono" pitchFamily="34" charset="-122"/>
                 <a:cs typeface="JetBrains Mono" pitchFamily="34" charset="-120"/>
               </a:rPr>
-              <a:t>);</a:t>
+              <a:t/>
             </a:r>
             <a:endParaRPr lang="en-US" sz="1350" dirty="0"/>
           </a:p>
@@ -8978,7 +8926,7 @@
                 <a:ea typeface="JetBrains Mono" pitchFamily="34" charset="-122"/>
                 <a:cs typeface="JetBrains Mono" pitchFamily="34" charset="-120"/>
               </a:rPr>
-              <a:t>const</a:t>
+              <a:t>const action = registry.get(id);</a:t>
             </a:r>
             <a:r>
               <a:rPr lang="en-US" sz="1350" dirty="0">
@@ -8989,7 +8937,7 @@
                 <a:ea typeface="JetBrains Mono" pitchFamily="34" charset="-122"/>
                 <a:cs typeface="JetBrains Mono" pitchFamily="34" charset="-120"/>
               </a:rPr>
-              <a:t> </a:t>
+              <a:t/>
             </a:r>
             <a:r>
               <a:rPr lang="en-US" sz="1350" dirty="0">
@@ -9000,7 +8948,7 @@
                 <a:ea typeface="JetBrains Mono" pitchFamily="34" charset="-122"/>
                 <a:cs typeface="JetBrains Mono" pitchFamily="34" charset="-120"/>
               </a:rPr>
-              <a:t>verdict</a:t>
+              <a:t/>
             </a:r>
             <a:r>
               <a:rPr lang="en-US" sz="1350" dirty="0">
@@ -9011,7 +8959,7 @@
                 <a:ea typeface="JetBrains Mono" pitchFamily="34" charset="-122"/>
                 <a:cs typeface="JetBrains Mono" pitchFamily="34" charset="-120"/>
               </a:rPr>
-              <a:t> </a:t>
+              <a:t/>
             </a:r>
             <a:r>
               <a:rPr lang="en-US" sz="1350" dirty="0">
@@ -9022,7 +8970,7 @@
                 <a:ea typeface="JetBrains Mono" pitchFamily="34" charset="-122"/>
                 <a:cs typeface="JetBrains Mono" pitchFamily="34" charset="-120"/>
               </a:rPr>
-              <a:t>=</a:t>
+              <a:t/>
             </a:r>
             <a:r>
               <a:rPr lang="en-US" sz="1350" dirty="0">
@@ -9033,7 +8981,7 @@
                 <a:ea typeface="JetBrains Mono" pitchFamily="34" charset="-122"/>
                 <a:cs typeface="JetBrains Mono" pitchFamily="34" charset="-120"/>
               </a:rPr>
-              <a:t> </a:t>
+              <a:t/>
             </a:r>
             <a:r>
               <a:rPr lang="en-US" sz="1350" dirty="0">
@@ -9044,7 +8992,7 @@
                 <a:ea typeface="JetBrains Mono" pitchFamily="34" charset="-122"/>
                 <a:cs typeface="JetBrains Mono" pitchFamily="34" charset="-120"/>
               </a:rPr>
-              <a:t>action</a:t>
+              <a:t/>
             </a:r>
             <a:r>
               <a:rPr lang="en-US" sz="1350" dirty="0">
@@ -9055,7 +9003,7 @@
                 <a:ea typeface="JetBrains Mono" pitchFamily="34" charset="-122"/>
                 <a:cs typeface="JetBrains Mono" pitchFamily="34" charset="-120"/>
               </a:rPr>
-              <a:t>.</a:t>
+              <a:t/>
             </a:r>
             <a:r>
               <a:rPr lang="en-US" sz="1350" dirty="0">
@@ -9066,7 +9014,7 @@
                 <a:ea typeface="JetBrains Mono" pitchFamily="34" charset="-122"/>
                 <a:cs typeface="JetBrains Mono" pitchFamily="34" charset="-120"/>
               </a:rPr>
-              <a:t>allowed</a:t>
+              <a:t/>
             </a:r>
             <a:r>
               <a:rPr lang="en-US" sz="1350" dirty="0">
@@ -9077,7 +9025,7 @@
                 <a:ea typeface="JetBrains Mono" pitchFamily="34" charset="-122"/>
                 <a:cs typeface="JetBrains Mono" pitchFamily="34" charset="-120"/>
               </a:rPr>
-              <a:t>(</a:t>
+              <a:t/>
             </a:r>
             <a:r>
               <a:rPr lang="en-US" sz="1350" dirty="0">
@@ -9088,7 +9036,7 @@
                 <a:ea typeface="JetBrains Mono" pitchFamily="34" charset="-122"/>
                 <a:cs typeface="JetBrains Mono" pitchFamily="34" charset="-120"/>
               </a:rPr>
-              <a:t>fresh</a:t>
+              <a:t/>
             </a:r>
             <a:r>
               <a:rPr lang="en-US" sz="1350" dirty="0">
@@ -9099,7 +9047,7 @@
                 <a:ea typeface="JetBrains Mono" pitchFamily="34" charset="-122"/>
                 <a:cs typeface="JetBrains Mono" pitchFamily="34" charset="-120"/>
               </a:rPr>
-              <a:t>);</a:t>
+              <a:t/>
             </a:r>
             <a:endParaRPr lang="en-US" sz="1350" dirty="0"/>
           </a:p>
@@ -9197,7 +9145,7 @@
                 <a:ea typeface="JetBrains Mono" pitchFamily="34" charset="-122"/>
                 <a:cs typeface="JetBrains Mono" pitchFamily="34" charset="-120"/>
               </a:rPr>
-              <a:t>if</a:t>
+              <a:t>if (!action?.allowed(fresh).ok) return;</a:t>
             </a:r>
             <a:r>
               <a:rPr lang="en-US" sz="1350" dirty="0">
@@ -9208,7 +9156,7 @@
                 <a:ea typeface="JetBrains Mono" pitchFamily="34" charset="-122"/>
                 <a:cs typeface="JetBrains Mono" pitchFamily="34" charset="-120"/>
               </a:rPr>
-              <a:t> </a:t>
+              <a:t/>
             </a:r>
             <a:r>
               <a:rPr lang="en-US" sz="1350" dirty="0">
@@ -9219,7 +9167,7 @@
                 <a:ea typeface="JetBrains Mono" pitchFamily="34" charset="-122"/>
                 <a:cs typeface="JetBrains Mono" pitchFamily="34" charset="-120"/>
               </a:rPr>
-              <a:t>(!</a:t>
+              <a:t/>
             </a:r>
             <a:r>
               <a:rPr lang="en-US" sz="1350" dirty="0">
@@ -9230,7 +9178,7 @@
                 <a:ea typeface="JetBrains Mono" pitchFamily="34" charset="-122"/>
                 <a:cs typeface="JetBrains Mono" pitchFamily="34" charset="-120"/>
               </a:rPr>
-              <a:t>verdict</a:t>
+              <a:t/>
             </a:r>
             <a:r>
               <a:rPr lang="en-US" sz="1350" dirty="0">
@@ -9241,7 +9189,7 @@
                 <a:ea typeface="JetBrains Mono" pitchFamily="34" charset="-122"/>
                 <a:cs typeface="JetBrains Mono" pitchFamily="34" charset="-120"/>
               </a:rPr>
-              <a:t>.</a:t>
+              <a:t/>
             </a:r>
             <a:r>
               <a:rPr lang="en-US" sz="1350" dirty="0">
@@ -9252,7 +9200,7 @@
                 <a:ea typeface="JetBrains Mono" pitchFamily="34" charset="-122"/>
                 <a:cs typeface="JetBrains Mono" pitchFamily="34" charset="-120"/>
               </a:rPr>
-              <a:t>ok</a:t>
+              <a:t/>
             </a:r>
             <a:r>
               <a:rPr lang="en-US" sz="1350" dirty="0">
@@ -9263,7 +9211,7 @@
                 <a:ea typeface="JetBrains Mono" pitchFamily="34" charset="-122"/>
                 <a:cs typeface="JetBrains Mono" pitchFamily="34" charset="-120"/>
               </a:rPr>
-              <a:t>)</a:t>
+              <a:t/>
             </a:r>
             <a:r>
               <a:rPr lang="en-US" sz="1350" dirty="0">
@@ -9274,7 +9222,7 @@
                 <a:ea typeface="JetBrains Mono" pitchFamily="34" charset="-122"/>
                 <a:cs typeface="JetBrains Mono" pitchFamily="34" charset="-120"/>
               </a:rPr>
-              <a:t> </a:t>
+              <a:t/>
             </a:r>
             <a:r>
               <a:rPr lang="en-US" sz="1350" dirty="0">
@@ -9285,7 +9233,7 @@
                 <a:ea typeface="JetBrains Mono" pitchFamily="34" charset="-122"/>
                 <a:cs typeface="JetBrains Mono" pitchFamily="34" charset="-120"/>
               </a:rPr>
-              <a:t>return</a:t>
+              <a:t/>
             </a:r>
             <a:r>
               <a:rPr lang="en-US" sz="1350" dirty="0">
@@ -9296,7 +9244,7 @@
                 <a:ea typeface="JetBrains Mono" pitchFamily="34" charset="-122"/>
                 <a:cs typeface="JetBrains Mono" pitchFamily="34" charset="-120"/>
               </a:rPr>
-              <a:t> </a:t>
+              <a:t/>
             </a:r>
             <a:r>
               <a:rPr lang="en-US" sz="1350" dirty="0">
@@ -9307,7 +9255,7 @@
                 <a:ea typeface="JetBrains Mono" pitchFamily="34" charset="-122"/>
                 <a:cs typeface="JetBrains Mono" pitchFamily="34" charset="-120"/>
               </a:rPr>
-              <a:t>replan</a:t>
+              <a:t/>
             </a:r>
             <a:r>
               <a:rPr lang="en-US" sz="1350" dirty="0">
@@ -9318,7 +9266,7 @@
                 <a:ea typeface="JetBrains Mono" pitchFamily="34" charset="-122"/>
                 <a:cs typeface="JetBrains Mono" pitchFamily="34" charset="-120"/>
               </a:rPr>
-              <a:t>(</a:t>
+              <a:t/>
             </a:r>
             <a:r>
               <a:rPr lang="en-US" sz="1350" dirty="0">
@@ -9329,7 +9277,7 @@
                 <a:ea typeface="JetBrains Mono" pitchFamily="34" charset="-122"/>
                 <a:cs typeface="JetBrains Mono" pitchFamily="34" charset="-120"/>
               </a:rPr>
-              <a:t>verdict</a:t>
+              <a:t/>
             </a:r>
             <a:r>
               <a:rPr lang="en-US" sz="1350" dirty="0">
@@ -9340,7 +9288,7 @@
                 <a:ea typeface="JetBrains Mono" pitchFamily="34" charset="-122"/>
                 <a:cs typeface="JetBrains Mono" pitchFamily="34" charset="-120"/>
               </a:rPr>
-              <a:t>.</a:t>
+              <a:t/>
             </a:r>
             <a:r>
               <a:rPr lang="en-US" sz="1350" dirty="0">
@@ -9351,7 +9299,7 @@
                 <a:ea typeface="JetBrains Mono" pitchFamily="34" charset="-122"/>
                 <a:cs typeface="JetBrains Mono" pitchFamily="34" charset="-120"/>
               </a:rPr>
-              <a:t>reason</a:t>
+              <a:t/>
             </a:r>
             <a:r>
               <a:rPr lang="en-US" sz="1350" dirty="0">
@@ -9362,7 +9310,7 @@
                 <a:ea typeface="JetBrains Mono" pitchFamily="34" charset="-122"/>
                 <a:cs typeface="JetBrains Mono" pitchFamily="34" charset="-120"/>
               </a:rPr>
-              <a:t>);</a:t>
+              <a:t/>
             </a:r>
             <a:endParaRPr lang="en-US" sz="1350" dirty="0"/>
           </a:p>
@@ -9460,7 +9408,7 @@
                 <a:ea typeface="JetBrains Mono" pitchFamily="34" charset="-122"/>
                 <a:cs typeface="JetBrains Mono" pitchFamily="34" charset="-120"/>
               </a:rPr>
-              <a:t>await</a:t>
+              <a:t>await action.run(browser);</a:t>
             </a:r>
             <a:r>
               <a:rPr lang="en-US" sz="1350" dirty="0">
@@ -9471,7 +9419,7 @@
                 <a:ea typeface="JetBrains Mono" pitchFamily="34" charset="-122"/>
                 <a:cs typeface="JetBrains Mono" pitchFamily="34" charset="-120"/>
               </a:rPr>
-              <a:t> </a:t>
+              <a:t/>
             </a:r>
             <a:r>
               <a:rPr lang="en-US" sz="1350" dirty="0">
@@ -9482,7 +9430,7 @@
                 <a:ea typeface="JetBrains Mono" pitchFamily="34" charset="-122"/>
                 <a:cs typeface="JetBrains Mono" pitchFamily="34" charset="-120"/>
               </a:rPr>
-              <a:t>action</a:t>
+              <a:t/>
             </a:r>
             <a:r>
               <a:rPr lang="en-US" sz="1350" dirty="0">
@@ -9493,7 +9441,7 @@
                 <a:ea typeface="JetBrains Mono" pitchFamily="34" charset="-122"/>
                 <a:cs typeface="JetBrains Mono" pitchFamily="34" charset="-120"/>
               </a:rPr>
-              <a:t>.</a:t>
+              <a:t/>
             </a:r>
             <a:r>
               <a:rPr lang="en-US" sz="1350" dirty="0">
@@ -9504,7 +9452,7 @@
                 <a:ea typeface="JetBrains Mono" pitchFamily="34" charset="-122"/>
                 <a:cs typeface="JetBrains Mono" pitchFamily="34" charset="-120"/>
               </a:rPr>
-              <a:t>run</a:t>
+              <a:t/>
             </a:r>
             <a:r>
               <a:rPr lang="en-US" sz="1350" dirty="0">
@@ -9515,7 +9463,7 @@
                 <a:ea typeface="JetBrains Mono" pitchFamily="34" charset="-122"/>
                 <a:cs typeface="JetBrains Mono" pitchFamily="34" charset="-120"/>
               </a:rPr>
-              <a:t>(</a:t>
+              <a:t/>
             </a:r>
             <a:r>
               <a:rPr lang="en-US" sz="1350" dirty="0">
@@ -9526,7 +9474,7 @@
                 <a:ea typeface="JetBrains Mono" pitchFamily="34" charset="-122"/>
                 <a:cs typeface="JetBrains Mono" pitchFamily="34" charset="-120"/>
               </a:rPr>
-              <a:t>browser</a:t>
+              <a:t/>
             </a:r>
             <a:r>
               <a:rPr lang="en-US" sz="1350" dirty="0">
@@ -9537,7 +9485,7 @@
                 <a:ea typeface="JetBrains Mono" pitchFamily="34" charset="-122"/>
                 <a:cs typeface="JetBrains Mono" pitchFamily="34" charset="-120"/>
               </a:rPr>
-              <a:t>);</a:t>
+              <a:t/>
             </a:r>
             <a:endParaRPr lang="en-US" sz="1350" dirty="0"/>
           </a:p>
@@ -9615,7 +9563,7 @@
                 <a:ea typeface="JetBrains Mono" pitchFamily="34" charset="-122"/>
                 <a:cs typeface="JetBrains Mono" pitchFamily="34" charset="-120"/>
               </a:rPr>
-              <a:t>return</a:t>
+              <a:t>return await readState(browser);</a:t>
             </a:r>
             <a:r>
               <a:rPr lang="en-US" sz="1350" dirty="0">
@@ -9626,7 +9574,7 @@
                 <a:ea typeface="JetBrains Mono" pitchFamily="34" charset="-122"/>
                 <a:cs typeface="JetBrains Mono" pitchFamily="34" charset="-120"/>
               </a:rPr>
-              <a:t> </a:t>
+              <a:t/>
             </a:r>
             <a:r>
               <a:rPr lang="en-US" sz="1350" dirty="0">
@@ -9637,7 +9585,7 @@
                 <a:ea typeface="JetBrains Mono" pitchFamily="34" charset="-122"/>
                 <a:cs typeface="JetBrains Mono" pitchFamily="34" charset="-120"/>
               </a:rPr>
-              <a:t>done</a:t>
+              <a:t/>
             </a:r>
             <a:r>
               <a:rPr lang="en-US" sz="1350" dirty="0">
@@ -9648,7 +9596,7 @@
                 <a:ea typeface="JetBrains Mono" pitchFamily="34" charset="-122"/>
                 <a:cs typeface="JetBrains Mono" pitchFamily="34" charset="-120"/>
               </a:rPr>
-              <a:t>(</a:t>
+              <a:t/>
             </a:r>
             <a:r>
               <a:rPr lang="en-US" sz="1350" dirty="0">
@@ -9659,7 +9607,7 @@
                 <a:ea typeface="JetBrains Mono" pitchFamily="34" charset="-122"/>
                 <a:cs typeface="JetBrains Mono" pitchFamily="34" charset="-120"/>
               </a:rPr>
-              <a:t>await</a:t>
+              <a:t/>
             </a:r>
             <a:r>
               <a:rPr lang="en-US" sz="1350" dirty="0">
@@ -9670,7 +9618,7 @@
                 <a:ea typeface="JetBrains Mono" pitchFamily="34" charset="-122"/>
                 <a:cs typeface="JetBrains Mono" pitchFamily="34" charset="-120"/>
               </a:rPr>
-              <a:t> </a:t>
+              <a:t/>
             </a:r>
             <a:r>
               <a:rPr lang="en-US" sz="1350" dirty="0">
@@ -9681,7 +9629,7 @@
                 <a:ea typeface="JetBrains Mono" pitchFamily="34" charset="-122"/>
                 <a:cs typeface="JetBrains Mono" pitchFamily="34" charset="-120"/>
               </a:rPr>
-              <a:t>readState</a:t>
+              <a:t/>
             </a:r>
             <a:r>
               <a:rPr lang="en-US" sz="1350" dirty="0">
@@ -9692,7 +9640,7 @@
                 <a:ea typeface="JetBrains Mono" pitchFamily="34" charset="-122"/>
                 <a:cs typeface="JetBrains Mono" pitchFamily="34" charset="-120"/>
               </a:rPr>
-              <a:t>(</a:t>
+              <a:t/>
             </a:r>
             <a:r>
               <a:rPr lang="en-US" sz="1350" dirty="0">
@@ -9703,7 +9651,7 @@
                 <a:ea typeface="JetBrains Mono" pitchFamily="34" charset="-122"/>
                 <a:cs typeface="JetBrains Mono" pitchFamily="34" charset="-120"/>
               </a:rPr>
-              <a:t>browser</a:t>
+              <a:t/>
             </a:r>
             <a:r>
               <a:rPr lang="en-US" sz="1350" dirty="0">
@@ -9714,7 +9662,7 @@
                 <a:ea typeface="JetBrains Mono" pitchFamily="34" charset="-122"/>
                 <a:cs typeface="JetBrains Mono" pitchFamily="34" charset="-120"/>
               </a:rPr>
-              <a:t>));</a:t>
+              <a:t/>
             </a:r>
             <a:endParaRPr lang="en-US" sz="1350" dirty="0"/>
           </a:p>
@@ -9753,7 +9701,7 @@
                 <a:ea typeface="Instrument Sans" pitchFamily="34" charset="-122"/>
                 <a:cs typeface="Assistant" pitchFamily="34" charset="-120"/>
               </a:rPr>
-              <a:t>מתוך src/executor.ts ב-wave-lab, מקוצר</a:t>
+              <a:t>loop.ts ו-executor.ts, מקוצר</a:t>
             </a:r>
             <a:endParaRPr lang="he-IL" sz="1200" dirty="0"/>
           </a:p>
@@ -10028,7 +9976,7 @@
                 <a:ea typeface="Instrument Sans" pitchFamily="34" charset="-122"/>
                 <a:cs typeface="Assistant" pitchFamily="34" charset="-120"/>
               </a:rPr>
-              <a:t>הפעולה קיימת?</a:t>
+              <a:t>העולם השתנה?</a:t>
             </a:r>
             <a:endParaRPr lang="he-IL" sz="1900" dirty="0"/>
           </a:p>
@@ -10067,7 +10015,7 @@
                 <a:ea typeface="Instrument Sans" pitchFamily="34" charset="-122"/>
                 <a:cs typeface="Assistant" pitchFamily="34" charset="-120"/>
               </a:rPr>
-              <a:t>מחפשים את המזהה ב-registry</a:t>
+              <a:t>ממתינים ומוודאים את גרסת ההחלטה</a:t>
             </a:r>
             <a:endParaRPr lang="he-IL" sz="1400" dirty="0"/>
           </a:p>
@@ -10188,7 +10136,7 @@
                 <a:ea typeface="Instrument Sans" pitchFamily="34" charset="-122"/>
                 <a:cs typeface="Assistant" pitchFamily="34" charset="-120"/>
               </a:rPr>
-              <a:t>היא עדיין מותרת?</a:t>
+              <a:t>התנאים עדיין מתקיימים?</a:t>
             </a:r>
             <a:endParaRPr lang="he-IL" sz="1900" dirty="0"/>
           </a:p>
@@ -10227,7 +10175,7 @@
                 <a:ea typeface="Instrument Sans" pitchFamily="34" charset="-122"/>
                 <a:cs typeface="Assistant" pitchFamily="34" charset="-120"/>
               </a:rPr>
-              <a:t>קוראים מצב עדכני ובודקים שוב</a:t>
+              <a:t>הבדיקה קוראת את התקציב העדכני</a:t>
             </a:r>
             <a:endParaRPr lang="he-IL" sz="1400" dirty="0"/>
           </a:p>
@@ -10600,7 +10548,7 @@
 </file>
 
 <file path=ppt/slides/slide14.xml><?xml version="1.0" encoding="utf-8"?>
-<p:sld xmlns:a="http://schemas.openxmlformats.org/drawingml/2006/main" xmlns:r="http://schemas.openxmlformats.org/officeDocument/2006/relationships" xmlns:p="http://schemas.openxmlformats.org/presentationml/2006/main">
+<p:sld xmlns:a="http://schemas.openxmlformats.org/drawingml/2006/main" xmlns:p="http://schemas.openxmlformats.org/presentationml/2006/main" xmlns:r="http://schemas.openxmlformats.org/officeDocument/2006/relationships">
   <p:cSld name="Slide 14">
     <p:bg>
       <p:bgPr>
@@ -10758,7 +10706,7 @@
                 <a:ea typeface="Fraunces" pitchFamily="34" charset="-122"/>
                 <a:cs typeface="Frank Ruhl Libre" pitchFamily="34" charset="-120"/>
               </a:rPr>
-              <a:t>אותה תקלה. עכשיו רואים את ההחלטות.</a:t>
+              <a:t>אותה ריצה. ההחלטה הישנה נדחית.</a:t>
             </a:r>
             <a:endParaRPr lang="he-IL" sz="3600" dirty="0"/>
           </a:p>
@@ -10859,7 +10807,7 @@
                 <a:ea typeface="Instrument Sans" pitchFamily="34" charset="-122"/>
                 <a:cs typeface="Assistant" pitchFamily="34" charset="-120"/>
               </a:rPr>
-              <a:t>המצב</a:t>
+              <a:t>השינוי</a:t>
             </a:r>
             <a:endParaRPr lang="he-IL" sz="1400" dirty="0"/>
           </a:p>
@@ -10898,7 +10846,7 @@
                 <a:ea typeface="Instrument Sans" pitchFamily="34" charset="-122"/>
                 <a:cs typeface="Assistant" pitchFamily="34" charset="-120"/>
               </a:rPr>
-              <a:t>מלון A מלא</a:t>
+              <a:t>A התמלא לפני הלחיצה</a:t>
             </a:r>
             <a:endParaRPr lang="he-IL" sz="2100" dirty="0"/>
           </a:p>
@@ -11101,7 +11049,7 @@
                 <a:ea typeface="Instrument Sans" pitchFamily="34" charset="-122"/>
                 <a:cs typeface="Assistant" pitchFamily="34" charset="-120"/>
               </a:rPr>
-              <a:t>הבחירה</a:t>
+              <a:t>הבדיקה</a:t>
             </a:r>
             <a:endParaRPr lang="he-IL" sz="1400" dirty="0"/>
           </a:p>
@@ -11140,7 +11088,7 @@
                 <a:ea typeface="Instrument Sans" pitchFamily="34" charset="-122"/>
                 <a:cs typeface="Assistant" pitchFamily="34" charset="-120"/>
               </a:rPr>
-              <a:t>חזרה לתוצאות</a:t>
+              <a:t>דחייה לפני לחיצה</a:t>
             </a:r>
             <a:endParaRPr lang="he-IL" sz="2100" dirty="0"/>
           </a:p>
@@ -11204,7 +11152,7 @@
                 <a:ea typeface="JetBrains Mono" pitchFamily="34" charset="-122"/>
                 <a:cs typeface="JetBrains Mono" pitchFamily="34" charset="-120"/>
               </a:rPr>
-              <a:t>choice</a:t>
+              <a:t>code: world_changed</a:t>
             </a:r>
             <a:r>
               <a:rPr lang="en-US" sz="1250" dirty="0">
@@ -11215,7 +11163,7 @@
                 <a:ea typeface="JetBrains Mono" pitchFamily="34" charset="-122"/>
                 <a:cs typeface="JetBrains Mono" pitchFamily="34" charset="-120"/>
               </a:rPr>
-              <a:t>:</a:t>
+              <a:t/>
             </a:r>
             <a:r>
               <a:rPr lang="en-US" sz="1250" dirty="0">
@@ -11226,7 +11174,7 @@
                 <a:ea typeface="JetBrains Mono" pitchFamily="34" charset="-122"/>
                 <a:cs typeface="JetBrains Mono" pitchFamily="34" charset="-120"/>
               </a:rPr>
-              <a:t> back_to_results</a:t>
+              <a:t/>
             </a:r>
             <a:endParaRPr lang="en-US" sz="1250" dirty="0"/>
           </a:p>
@@ -11770,7 +11718,7 @@
 </file>
 
 <file path=ppt/slides/slide15.xml><?xml version="1.0" encoding="utf-8"?>
-<p:sld xmlns:a="http://schemas.openxmlformats.org/drawingml/2006/main" xmlns:r="http://schemas.openxmlformats.org/officeDocument/2006/relationships" xmlns:p="http://schemas.openxmlformats.org/presentationml/2006/main">
+<p:sld xmlns:a="http://schemas.openxmlformats.org/drawingml/2006/main" xmlns:p="http://schemas.openxmlformats.org/presentationml/2006/main" xmlns:r="http://schemas.openxmlformats.org/officeDocument/2006/relationships">
   <p:cSld name="Slide 15">
     <p:bg>
       <p:bgPr>
@@ -12138,7 +12086,7 @@
                 <a:ea typeface="Fraunces" pitchFamily="34" charset="-122"/>
                 <a:cs typeface="Frank Ruhl Libre" pitchFamily="34" charset="-120"/>
               </a:rPr>
-              <a:t>הסוכן שואל.</a:t>
+              <a:t>הסוכן ממתין.</a:t>
             </a:r>
             <a:endParaRPr lang="he-IL" sz="3000" dirty="0"/>
           </a:p>
@@ -12177,7 +12125,7 @@
                 <a:ea typeface="Fraunces" pitchFamily="34" charset="-122"/>
                 <a:cs typeface="Frank Ruhl Libre" pitchFamily="34" charset="-120"/>
               </a:rPr>
-              <a:t>הוא לא משנה תנאים לבד.</a:t>
+              <a:t>משחזרים תקציב באותה ריצה.</a:t>
             </a:r>
             <a:endParaRPr lang="he-IL" sz="3000" dirty="0"/>
           </a:p>
@@ -12259,7 +12207,7 @@
                 <a:ea typeface="Instrument Sans" pitchFamily="34" charset="-122"/>
                 <a:cs typeface="Assistant" pitchFamily="34" charset="-120"/>
               </a:rPr>
-              <a:t>לכן: </a:t>
+              <a:t>בטרמינל: budget 600 ואז run</a:t>
             </a:r>
             <a:r>
               <a:rPr lang="he-IL" altLang="en-US" sz="1600" dirty="0">
@@ -12270,7 +12218,7 @@
                 <a:ea typeface="Instrument Sans" pitchFamily="34" charset="-122"/>
                 <a:cs typeface="Assistant" pitchFamily="34" charset="-120"/>
               </a:rPr>
-              <a:t>ברשימה תמיד יש stop, ויש מגבלת צעדים.</a:t>
+              <a:t/>
             </a:r>
             <a:endParaRPr lang="he-IL" sz="1600" dirty="0"/>
           </a:p>
@@ -12285,7 +12233,7 @@
 </file>
 
 <file path=ppt/slides/slide16.xml><?xml version="1.0" encoding="utf-8"?>
-<p:sld xmlns:a="http://schemas.openxmlformats.org/drawingml/2006/main" xmlns:r="http://schemas.openxmlformats.org/officeDocument/2006/relationships" xmlns:p="http://schemas.openxmlformats.org/presentationml/2006/main">
+<p:sld xmlns:a="http://schemas.openxmlformats.org/drawingml/2006/main" xmlns:p="http://schemas.openxmlformats.org/presentationml/2006/main" xmlns:r="http://schemas.openxmlformats.org/officeDocument/2006/relationships">
   <p:cSld name="Slide 16">
     <p:bg>
       <p:bgPr>
@@ -14626,7 +14574,7 @@
 </file>
 
 <file path=ppt/slides/slide19.xml><?xml version="1.0" encoding="utf-8"?>
-<p:sld xmlns:a="http://schemas.openxmlformats.org/drawingml/2006/main" xmlns:r="http://schemas.openxmlformats.org/officeDocument/2006/relationships" xmlns:p="http://schemas.openxmlformats.org/presentationml/2006/main">
+<p:sld xmlns:a="http://schemas.openxmlformats.org/drawingml/2006/main" xmlns:p="http://schemas.openxmlformats.org/presentationml/2006/main" xmlns:r="http://schemas.openxmlformats.org/officeDocument/2006/relationships">
   <p:cSld name="Slide 19">
     <p:bg>
       <p:bgPr>
@@ -14784,7 +14732,7 @@
                 <a:ea typeface="Fraunces" pitchFamily="34" charset="-122"/>
                 <a:cs typeface="Frank Ruhl Libre" pitchFamily="34" charset="-120"/>
               </a:rPr>
-              <a:t>מתי חוזרים למתכנן?</a:t>
+              <a:t>מתי מוצר יכול לחזור למתכנן?</a:t>
             </a:r>
             <a:endParaRPr lang="he-IL" sz="3800" dirty="0"/>
           </a:p>
@@ -18968,7 +18916,7 @@
 </file>
 
 <file path=ppt/slides/slide4.xml><?xml version="1.0" encoding="utf-8"?>
-<p:sld xmlns:a="http://schemas.openxmlformats.org/drawingml/2006/main" xmlns:r="http://schemas.openxmlformats.org/officeDocument/2006/relationships" xmlns:p="http://schemas.openxmlformats.org/presentationml/2006/main">
+<p:sld xmlns:a="http://schemas.openxmlformats.org/drawingml/2006/main" xmlns:p="http://schemas.openxmlformats.org/presentationml/2006/main" xmlns:r="http://schemas.openxmlformats.org/officeDocument/2006/relationships">
   <p:cSld name="Slide 4">
     <p:bg>
       <p:bgPr>
@@ -19150,7 +19098,7 @@
                 <a:ea typeface="Fraunces" pitchFamily="34" charset="-122"/>
                 <a:cs typeface="Frank Ruhl Libre" pitchFamily="34" charset="-120"/>
               </a:rPr>
-              <a:t>הדפדפן על המסך</a:t>
+              <a:t>השליטה בטרמינל</a:t>
             </a:r>
             <a:endParaRPr lang="he-IL" sz="4000" dirty="0"/>
           </a:p>
@@ -19570,7 +19518,7 @@
                 <a:ea typeface="Instrument Sans" pitchFamily="34" charset="-122"/>
                 <a:cs typeface="Assistant" pitchFamily="34" charset="-120"/>
               </a:rPr>
-              <a:t>המחשה מקומית, בלי קריאה למודל</a:t>
+              <a:t>בחירות מתוסרטות. בלי קריאות מודל</a:t>
             </a:r>
             <a:endParaRPr lang="he-IL" sz="1200" dirty="0"/>
           </a:p>
@@ -19585,7 +19533,7 @@
 </file>
 
 <file path=ppt/slides/slide5.xml><?xml version="1.0" encoding="utf-8"?>
-<p:sld xmlns:a="http://schemas.openxmlformats.org/drawingml/2006/main" xmlns:r="http://schemas.openxmlformats.org/officeDocument/2006/relationships" xmlns:p="http://schemas.openxmlformats.org/presentationml/2006/main">
+<p:sld xmlns:a="http://schemas.openxmlformats.org/drawingml/2006/main" xmlns:p="http://schemas.openxmlformats.org/presentationml/2006/main" xmlns:r="http://schemas.openxmlformats.org/officeDocument/2006/relationships">
   <p:cSld name="Slide 5">
     <p:bg>
       <p:bgPr>
@@ -19767,7 +19715,7 @@
                 <a:ea typeface="Fraunces" pitchFamily="34" charset="-122"/>
                 <a:cs typeface="Frank Ruhl Libre" pitchFamily="34" charset="-120"/>
               </a:rPr>
-              <a:t>מצאתי מלון!</a:t>
+              <a:t>בחרתי מלון!</a:t>
             </a:r>
             <a:endParaRPr lang="he-IL" sz="4000" dirty="0"/>
           </a:p>
@@ -19829,7 +19777,7 @@
                 <a:ea typeface="Instrument Sans" pitchFamily="34" charset="-122"/>
                 <a:cs typeface="Assistant" pitchFamily="34" charset="-120"/>
               </a:rPr>
-              <a:t>המלון: ״היה נעים להכיר״</a:t>
+              <a:t>מלון A במחיר €520. עוד לא לחצנו.</a:t>
             </a:r>
             <a:endParaRPr lang="he-IL" sz="1800" dirty="0"/>
           </a:p>
@@ -19868,7 +19816,7 @@
                 <a:ea typeface="Instrument Sans" pitchFamily="34" charset="-122"/>
                 <a:cs typeface="Assistant" pitchFamily="34" charset="-120"/>
               </a:rPr>
-              <a:t>ועכשיו אתם מחליטים מה ישתבש:</a:t>
+              <a:t>אתם משנים את התנאים באותה ריצה:</a:t>
             </a:r>
             <a:endParaRPr lang="he-IL" sz="1700" dirty="0"/>
           </a:p>
@@ -22623,7 +22571,7 @@
 </file>
 
 <file path=ppt/slides/slide8.xml><?xml version="1.0" encoding="utf-8"?>
-<p:sld xmlns:a="http://schemas.openxmlformats.org/drawingml/2006/main" xmlns:r="http://schemas.openxmlformats.org/officeDocument/2006/relationships" xmlns:p="http://schemas.openxmlformats.org/presentationml/2006/main">
+<p:sld xmlns:a="http://schemas.openxmlformats.org/drawingml/2006/main" xmlns:p="http://schemas.openxmlformats.org/presentationml/2006/main" xmlns:r="http://schemas.openxmlformats.org/officeDocument/2006/relationships">
   <p:cSld name="Slide 8">
     <p:bg>
       <p:bgPr>
@@ -23147,7 +23095,7 @@
                 <a:ea typeface="Instrument Sans" pitchFamily="34" charset="-122"/>
                 <a:cs typeface="Assistant" pitchFamily="34" charset="-120"/>
               </a:rPr>
-              <a:t>שני מודלים: </a:t>
+              <a:t>המטרה נקבעת בקוד. Jev בוחר איזו פעולה עכשיו.</a:t>
             </a:r>
             <a:r>
               <a:rPr lang="he-IL" altLang="en-US" sz="1500" dirty="0">
@@ -23158,7 +23106,7 @@
                 <a:ea typeface="Instrument Sans" pitchFamily="34" charset="-122"/>
                 <a:cs typeface="Assistant" pitchFamily="34" charset="-120"/>
               </a:rPr>
-              <a:t>המתכנן מחליט מה המטרה. Jev בוחר איזו פעולה עכשיו.</a:t>
+              <a:t/>
             </a:r>
             <a:endParaRPr lang="he-IL" sz="1500" dirty="0"/>
           </a:p>

</xml_diff>